<commit_message>
Presentation : correction du format des slides et du nombre d'agences
- Format des diapositives corrige : le layout etait genere en 10 x 5,625"
  alors que la mise en page etait calculee pour 13,333 x 7,5", ce qui faisait
  deborder tout le contenu hors de la page. Layout 16:9 large defini
  explicitement.
- Nombre d'agences corrige : 45 au lieu de 49 (contexte, chiffres du reseau
  et chaine ETL).

Co-Authored-By: Claude Opus 4.8 <noreply@anthropic.com>
Claude-Session: https://claude.ai/code/session_01XrCEv79rD628gYBfC2XWx6
</commit_message>
<xml_diff>
--- a/presentation/Soutenance_PFE_Oussema_Korbosli.pptx
+++ b/presentation/Soutenance_PFE_Oussema_Korbosli.pptx
@@ -45,8 +45,8 @@
   <p:notesMasterIdLst>
     <p:notesMasterId r:id="rId38"/>
   </p:notesMasterIdLst>
-  <p:sldSz cx="9144000" cy="5143500"/>
-  <p:notesSz cx="5143500" cy="9144000"/>
+  <p:sldSz cx="12191695" cy="6858000"/>
+  <p:notesSz cx="6858000" cy="12191695"/>
   <p:defaultTextStyle>
     <a:lvl1pPr marL="0" algn="l" defTabSz="914400" rtl="0" eaLnBrk="1" latinLnBrk="0" hangingPunct="1">
       <a:defRPr sz="1800" kern="1200">
@@ -14929,7 +14929,7 @@
                 <a:ea typeface="Georgia" pitchFamily="34" charset="-122"/>
                 <a:cs typeface="Georgia" pitchFamily="34" charset="-120"/>
               </a:rPr>
-              <a:t>49</a:t>
+              <a:t>45</a:t>
             </a:r>
             <a:endParaRPr lang="en-US" sz="2600" dirty="0"/>
           </a:p>
@@ -25971,7 +25971,7 @@
                 <a:ea typeface="Calibri" pitchFamily="34" charset="-122"/>
                 <a:cs typeface="Calibri" pitchFamily="34" charset="-120"/>
               </a:rPr>
-              <a:t>Un réseau de 49 agences réparties sur tout le territoire tunisien</a:t>
+              <a:t>Un réseau de 45 agences réparties sur tout le territoire tunisien</a:t>
             </a:r>
             <a:endParaRPr lang="en-US" sz="1400" dirty="0"/>
           </a:p>
@@ -27578,7 +27578,7 @@
                 <a:ea typeface="Georgia" pitchFamily="34" charset="-122"/>
                 <a:cs typeface="Georgia" pitchFamily="34" charset="-120"/>
               </a:rPr>
-              <a:t>49</a:t>
+              <a:t>45</a:t>
             </a:r>
             <a:endParaRPr lang="en-US" sz="2600" dirty="0"/>
           </a:p>

</xml_diff>

<commit_message>
Presentation alignee sur la nouvelle segmentation
Mise a jour du zoom technique et des resultats de segmentation avec les
valeurs calculees sur les donnees reelles (silhouette 0,604, six variables,
log sur les montants) et les trois nouveaux segments : 34 agences
d'exploitation, 6 entites de production, 8 entites sans activite.

Co-Authored-By: Claude Opus 4.8 <noreply@anthropic.com>
Claude-Session: https://claude.ai/code/session_01XrCEv79rD628gYBfC2XWx6
</commit_message>
<xml_diff>
--- a/presentation/Soutenance_PFE_Oussema_Korbosli.pptx
+++ b/presentation/Soutenance_PFE_Oussema_Korbosli.pptx
@@ -21419,7 +21419,7 @@
                 <a:ea typeface="Calibri" pitchFamily="34" charset="-122"/>
                 <a:cs typeface="Calibri" pitchFamily="34" charset="-120"/>
               </a:rPr>
-              <a:t>Principe : regrouper les agences en profils homogènes à partir de leurs sept indicateurs, sans étiquette préalable (apprentissage non supervisé).</a:t>
+              <a:t>Principe : regrouper les agences en profils homogènes à partir de six indicateurs réels, sans étiquette préalable (apprentissage non supervisé).</a:t>
             </a:r>
             <a:endParaRPr lang="en-US" sz="1300" dirty="0"/>
           </a:p>
@@ -21546,7 +21546,7 @@
                 <a:ea typeface="Georgia" pitchFamily="34" charset="-122"/>
                 <a:cs typeface="Georgia" pitchFamily="34" charset="-120"/>
               </a:rPr>
-              <a:t>Standardisation</a:t>
+              <a:t>Prétraitement</a:t>
             </a:r>
             <a:endParaRPr lang="en-US" sz="1400" dirty="0"/>
           </a:p>
@@ -21585,7 +21585,7 @@
                 <a:ea typeface="Calibri" pitchFamily="34" charset="-122"/>
                 <a:cs typeface="Calibri" pitchFamily="34" charset="-120"/>
               </a:rPr>
-              <a:t>Centrage-réduction des 7 variables (StandardScaler)</a:t>
+              <a:t>Log sur les montants puis centrage-réduction (6 variables)</a:t>
             </a:r>
             <a:endParaRPr lang="en-US" sz="1150" dirty="0"/>
           </a:p>
@@ -21751,7 +21751,7 @@
                 <a:ea typeface="Calibri" pitchFamily="34" charset="-122"/>
                 <a:cs typeface="Calibri" pitchFamily="34" charset="-120"/>
               </a:rPr>
-              <a:t>Méthode du coude et score de silhouette → k = 3</a:t>
+              <a:t>Coude et silhouette → k = 3, exploitable pour le pilotage</a:t>
             </a:r>
             <a:endParaRPr lang="en-US" sz="1150" dirty="0"/>
           </a:p>
@@ -22083,7 +22083,7 @@
                 <a:ea typeface="Calibri" pitchFamily="34" charset="-122"/>
                 <a:cs typeface="Calibri" pitchFamily="34" charset="-120"/>
               </a:rPr>
-              <a:t>K-Means : silhouette 0,736 · Davies-Bouldin 0,350</a:t>
+              <a:t>K-Means : silhouette 0,604, classe toutes les agences</a:t>
             </a:r>
             <a:endParaRPr lang="en-US" sz="1150" dirty="0"/>
           </a:p>
@@ -22105,8 +22105,8 @@
         </p:blipFill>
         <p:spPr>
           <a:xfrm>
-            <a:off x="6446520" y="2150269"/>
-            <a:ext cx="5212080" cy="3746183"/>
+            <a:off x="6446520" y="2216506"/>
+            <a:ext cx="5212080" cy="3613709"/>
           </a:xfrm>
           <a:prstGeom prst="rect">
             <a:avLst/>
@@ -22382,7 +22382,7 @@
                 <a:ea typeface="Georgia" pitchFamily="34" charset="-122"/>
                 <a:cs typeface="Georgia" pitchFamily="34" charset="-120"/>
               </a:rPr>
-              <a:t>7</a:t>
+              <a:t>34</a:t>
             </a:r>
             <a:endParaRPr lang="en-US" sz="3400" dirty="0"/>
           </a:p>
@@ -22421,7 +22421,7 @@
                 <a:ea typeface="Georgia" pitchFamily="34" charset="-122"/>
                 <a:cs typeface="Georgia" pitchFamily="34" charset="-120"/>
               </a:rPr>
-              <a:t>Grandes agences</a:t>
+              <a:t>Agences d'exploitation</a:t>
             </a:r>
             <a:endParaRPr lang="en-US" sz="1550" dirty="0"/>
           </a:p>
@@ -22463,7 +22463,7 @@
                 <a:ea typeface="Calibri" pitchFamily="34" charset="-122"/>
                 <a:cs typeface="Calibri" pitchFamily="34" charset="-120"/>
               </a:rPr>
-              <a:t>Effectif et production élevés · présence 0,98</a:t>
+              <a:t>880 clients · 12 employés · 7,80 MDT de crédits</a:t>
             </a:r>
             <a:endParaRPr lang="en-US" sz="1150" dirty="0"/>
           </a:p>
@@ -22525,7 +22525,7 @@
                 <a:ea typeface="Calibri" pitchFamily="34" charset="-122"/>
                 <a:cs typeface="Calibri" pitchFamily="34" charset="-120"/>
               </a:rPr>
-              <a:t>Objectifs ambitieux, agences de référence</a:t>
+              <a:t>Objectifs différenciés, diffusion des bonnes pratiques</a:t>
             </a:r>
             <a:endParaRPr lang="en-US" sz="1200" dirty="0"/>
           </a:p>
@@ -22611,7 +22611,7 @@
                 <a:ea typeface="Georgia" pitchFamily="34" charset="-122"/>
                 <a:cs typeface="Georgia" pitchFamily="34" charset="-120"/>
               </a:rPr>
-              <a:t>16</a:t>
+              <a:t>6</a:t>
             </a:r>
             <a:endParaRPr lang="en-US" sz="3400" dirty="0"/>
           </a:p>
@@ -22650,7 +22650,7 @@
                 <a:ea typeface="Georgia" pitchFamily="34" charset="-122"/>
                 <a:cs typeface="Georgia" pitchFamily="34" charset="-120"/>
               </a:rPr>
-              <a:t>Agences moyennes</a:t>
+              <a:t>Entités de production</a:t>
             </a:r>
             <a:endParaRPr lang="en-US" sz="1550" dirty="0"/>
           </a:p>
@@ -22692,7 +22692,7 @@
                 <a:ea typeface="Calibri" pitchFamily="34" charset="-122"/>
                 <a:cs typeface="Calibri" pitchFamily="34" charset="-120"/>
               </a:rPr>
-              <a:t>Activité intermédiaire · présence 0,94</a:t>
+              <a:t>Quasi aucun client · 14,61 MDT de crédits</a:t>
             </a:r>
             <a:endParaRPr lang="en-US" sz="1150" dirty="0"/>
           </a:p>
@@ -22754,7 +22754,7 @@
                 <a:ea typeface="Calibri" pitchFamily="34" charset="-122"/>
                 <a:cs typeface="Calibri" pitchFamily="34" charset="-120"/>
               </a:rPr>
-              <a:t>Fort potentiel : équipement et collecte</a:t>
+              <a:t>Analyser ces financements réalisés hors guichet</a:t>
             </a:r>
             <a:endParaRPr lang="en-US" sz="1200" dirty="0"/>
           </a:p>
@@ -22840,7 +22840,7 @@
                 <a:ea typeface="Georgia" pitchFamily="34" charset="-122"/>
                 <a:cs typeface="Georgia" pitchFamily="34" charset="-120"/>
               </a:rPr>
-              <a:t>22</a:t>
+              <a:t>8</a:t>
             </a:r>
             <a:endParaRPr lang="en-US" sz="3400" dirty="0"/>
           </a:p>
@@ -22879,7 +22879,7 @@
                 <a:ea typeface="Georgia" pitchFamily="34" charset="-122"/>
                 <a:cs typeface="Georgia" pitchFamily="34" charset="-120"/>
               </a:rPr>
-              <a:t>Petites agences</a:t>
+              <a:t>Entités sans activité</a:t>
             </a:r>
             <a:endParaRPr lang="en-US" sz="1550" dirty="0"/>
           </a:p>
@@ -22921,7 +22921,7 @@
                 <a:ea typeface="Calibri" pitchFamily="34" charset="-122"/>
                 <a:cs typeface="Calibri" pitchFamily="34" charset="-120"/>
               </a:rPr>
-              <a:t>Effectif et activité réduits · présence 0,87</a:t>
+              <a:t>Ni clientèle, ni comptes, ni production</a:t>
             </a:r>
             <a:endParaRPr lang="en-US" sz="1150" dirty="0"/>
           </a:p>
@@ -22983,7 +22983,7 @@
                 <a:ea typeface="Calibri" pitchFamily="34" charset="-122"/>
                 <a:cs typeface="Calibri" pitchFamily="34" charset="-120"/>
               </a:rPr>
-              <a:t>Accompagnement ciblé et suivi de l'assiduité</a:t>
+              <a:t>Statuer : ouverture, rattachement ou intégration</a:t>
             </a:r>
             <a:endParaRPr lang="en-US" sz="1200" dirty="0"/>
           </a:p>
@@ -23049,7 +23049,7 @@
                 <a:ea typeface="Calibri" pitchFamily="34" charset="-122"/>
                 <a:cs typeface="Calibri" pitchFamily="34" charset="-120"/>
               </a:rPr>
-              <a:t>Apport décisionnel : allouer les ressources selon la taille, différencier les objectifs et accompagner les agences les plus fragiles</a:t>
+              <a:t>Apport décisionnel : différencier les objectifs selon le régime d'activité réel et fiabiliser le référentiel</a:t>
             </a:r>
             <a:endParaRPr lang="en-US" sz="1250" dirty="0"/>
           </a:p>

</xml_diff>

<commit_message>
Presentation : schema du cycle CRISP-DM sur la slide methodologie
Ajout d'un diagramme du cycle CRISP-DM (six phases disposees en roue autour
des donnees, fleches du cycle et anneau iteratif) aux couleurs de la
presentation, genere par clustering/gen_crispdm.py. La slide methodologie
associe desormais le schema a gauche et la justification du choix
(pourquoi CRISP-DM, correspondance avec les chapitres) a droite.

Co-Authored-By: Claude Opus 4.8 <noreply@anthropic.com>
Claude-Session: https://claude.ai/code/session_01XrCEv79rD628gYBfC2XWx6
</commit_message>
<xml_diff>
--- a/presentation/Soutenance_PFE_Oussema_Korbosli.pptx
+++ b/presentation/Soutenance_PFE_Oussema_Korbosli.pptx
@@ -4777,7 +4777,7 @@
         </p:nvSpPr>
         <p:spPr>
           <a:xfrm>
-            <a:off x="566928" y="1417320"/>
+            <a:off x="566928" y="1298448"/>
             <a:ext cx="11064240" cy="457200"/>
           </a:xfrm>
           <a:prstGeom prst="rect">
@@ -4808,747 +4808,63 @@
           </a:p>
         </p:txBody>
       </p:sp>
-      <p:sp>
-        <p:nvSpPr>
-          <p:cNvPr id="8" name="Shape 6"/>
-          <p:cNvSpPr/>
-          <p:nvPr/>
-        </p:nvSpPr>
-        <p:spPr>
-          <a:xfrm>
-            <a:off x="566928" y="2011680"/>
-            <a:ext cx="1691640" cy="1417320"/>
-          </a:xfrm>
-          <a:prstGeom prst="roundRect">
-            <a:avLst>
-              <a:gd name="adj" fmla="val 5161"/>
-            </a:avLst>
-          </a:prstGeom>
-          <a:solidFill>
-            <a:srgbClr val="0A2558"/>
-          </a:solidFill>
-          <a:ln w="12700">
-            <a:solidFill>
-              <a:srgbClr val="0A2558"/>
-            </a:solidFill>
-            <a:prstDash val="solid"/>
-          </a:ln>
-        </p:spPr>
-      </p:sp>
-      <p:sp>
-        <p:nvSpPr>
-          <p:cNvPr id="9" name="Text 7"/>
-          <p:cNvSpPr/>
-          <p:nvPr/>
-        </p:nvSpPr>
-        <p:spPr>
-          <a:xfrm>
-            <a:off x="566928" y="2139696"/>
-            <a:ext cx="1691640" cy="310896"/>
-          </a:xfrm>
-          <a:prstGeom prst="rect">
-            <a:avLst/>
-          </a:prstGeom>
-          <a:noFill/>
-          <a:ln/>
-        </p:spPr>
-        <p:txBody>
-          <a:bodyPr wrap="square" lIns="0" tIns="0" rIns="0" bIns="0" rtlCol="0" anchor="ctr"/>
-          <a:lstStyle/>
-          <a:p>
-            <a:pPr algn="ctr" indent="0" marL="0">
-              <a:buNone/>
-            </a:pPr>
-            <a:r>
-              <a:rPr lang="en-US" sz="1400" b="1" dirty="0">
+      <p:pic>
+        <p:nvPicPr>
+          <p:cNvPr id="8" name="Image 0" descr="/home/user/oussema_korbosli/rapport-latex/images/crispdm.png">    </p:cNvPr>
+          <p:cNvPicPr>
+            <a:picLocks noChangeAspect="1"/>
+          </p:cNvPicPr>
+          <p:nvPr/>
+        </p:nvPicPr>
+        <p:blipFill>
+          <a:blip r:embed="rId1"/>
+          <a:stretch>
+            <a:fillRect/>
+          </a:stretch>
+        </p:blipFill>
+        <p:spPr>
+          <a:xfrm>
+            <a:off x="888073" y="1783080"/>
+            <a:ext cx="5301310" cy="4343400"/>
+          </a:xfrm>
+          <a:prstGeom prst="rect">
+            <a:avLst/>
+          </a:prstGeom>
+        </p:spPr>
+      </p:pic>
+      <p:sp>
+        <p:nvSpPr>
+          <p:cNvPr id="9" name="Text 6"/>
+          <p:cNvSpPr/>
+          <p:nvPr/>
+        </p:nvSpPr>
+        <p:spPr>
+          <a:xfrm>
+            <a:off x="6720840" y="1828800"/>
+            <a:ext cx="4937760" cy="274320"/>
+          </a:xfrm>
+          <a:prstGeom prst="rect">
+            <a:avLst/>
+          </a:prstGeom>
+          <a:noFill/>
+          <a:ln/>
+        </p:spPr>
+        <p:txBody>
+          <a:bodyPr wrap="square" lIns="0" tIns="0" rIns="0" bIns="0" rtlCol="0" anchor="ctr"/>
+          <a:lstStyle/>
+          <a:p>
+            <a:pPr indent="0" marL="0">
+              <a:buNone/>
+            </a:pPr>
+            <a:r>
+              <a:rPr lang="en-US" sz="1050" b="1" spc="200" kern="0" dirty="0">
                 <a:solidFill>
                   <a:srgbClr val="3C6FC3"/>
-                </a:solidFill>
-                <a:latin typeface="Georgia" pitchFamily="34" charset="0"/>
-                <a:ea typeface="Georgia" pitchFamily="34" charset="-122"/>
-                <a:cs typeface="Georgia" pitchFamily="34" charset="-120"/>
-              </a:rPr>
-              <a:t>01</a:t>
-            </a:r>
-            <a:endParaRPr lang="en-US" sz="1400" dirty="0"/>
-          </a:p>
-        </p:txBody>
-      </p:sp>
-      <p:sp>
-        <p:nvSpPr>
-          <p:cNvPr id="10" name="Text 8"/>
-          <p:cNvSpPr/>
-          <p:nvPr/>
-        </p:nvSpPr>
-        <p:spPr>
-          <a:xfrm>
-            <a:off x="640080" y="2487168"/>
-            <a:ext cx="1545336" cy="841248"/>
-          </a:xfrm>
-          <a:prstGeom prst="rect">
-            <a:avLst/>
-          </a:prstGeom>
-          <a:noFill/>
-          <a:ln/>
-        </p:spPr>
-        <p:txBody>
-          <a:bodyPr wrap="square" lIns="0" tIns="0" rIns="0" bIns="0" rtlCol="0" anchor="t"/>
-          <a:lstStyle/>
-          <a:p>
-            <a:pPr algn="ctr" indent="0" marL="0">
-              <a:lnSpc>
-                <a:spcPts val="1500"/>
-              </a:lnSpc>
-              <a:buNone/>
-            </a:pPr>
-            <a:r>
-              <a:rPr lang="en-US" sz="1150" dirty="0">
-                <a:solidFill>
-                  <a:srgbClr val="FFFFFF"/>
                 </a:solidFill>
                 <a:latin typeface="Calibri" pitchFamily="34" charset="0"/>
                 <a:ea typeface="Calibri" pitchFamily="34" charset="-122"/>
                 <a:cs typeface="Calibri" pitchFamily="34" charset="-120"/>
               </a:rPr>
-              <a:t>Compréhension</a:t>
-            </a:r>
-            <a:endParaRPr lang="en-US" sz="1150" dirty="0"/>
-          </a:p>
-          <a:p>
-            <a:pPr algn="ctr" indent="0" marL="0">
-              <a:lnSpc>
-                <a:spcPts val="1500"/>
-              </a:lnSpc>
-              <a:buNone/>
-            </a:pPr>
-            <a:r>
-              <a:rPr lang="en-US" sz="1150" dirty="0">
-                <a:solidFill>
-                  <a:srgbClr val="FFFFFF"/>
-                </a:solidFill>
-                <a:latin typeface="Calibri" pitchFamily="34" charset="0"/>
-                <a:ea typeface="Calibri" pitchFamily="34" charset="-122"/>
-                <a:cs typeface="Calibri" pitchFamily="34" charset="-120"/>
-              </a:rPr>
-              <a:t>métier</a:t>
-            </a:r>
-            <a:endParaRPr lang="en-US" sz="1150" dirty="0"/>
-          </a:p>
-        </p:txBody>
-      </p:sp>
-      <p:sp>
-        <p:nvSpPr>
-          <p:cNvPr id="11" name="Shape 9"/>
-          <p:cNvSpPr/>
-          <p:nvPr/>
-        </p:nvSpPr>
-        <p:spPr>
-          <a:xfrm>
-            <a:off x="2423160" y="2011680"/>
-            <a:ext cx="1691640" cy="1417320"/>
-          </a:xfrm>
-          <a:prstGeom prst="roundRect">
-            <a:avLst>
-              <a:gd name="adj" fmla="val 5161"/>
-            </a:avLst>
-          </a:prstGeom>
-          <a:solidFill>
-            <a:srgbClr val="1D4EA0"/>
-          </a:solidFill>
-          <a:ln w="12700">
-            <a:solidFill>
-              <a:srgbClr val="1D4EA0"/>
-            </a:solidFill>
-            <a:prstDash val="solid"/>
-          </a:ln>
-        </p:spPr>
-      </p:sp>
-      <p:sp>
-        <p:nvSpPr>
-          <p:cNvPr id="12" name="Text 10"/>
-          <p:cNvSpPr/>
-          <p:nvPr/>
-        </p:nvSpPr>
-        <p:spPr>
-          <a:xfrm>
-            <a:off x="2423160" y="2139696"/>
-            <a:ext cx="1691640" cy="310896"/>
-          </a:xfrm>
-          <a:prstGeom prst="rect">
-            <a:avLst/>
-          </a:prstGeom>
-          <a:noFill/>
-          <a:ln/>
-        </p:spPr>
-        <p:txBody>
-          <a:bodyPr wrap="square" lIns="0" tIns="0" rIns="0" bIns="0" rtlCol="0" anchor="ctr"/>
-          <a:lstStyle/>
-          <a:p>
-            <a:pPr algn="ctr" indent="0" marL="0">
-              <a:buNone/>
-            </a:pPr>
-            <a:r>
-              <a:rPr lang="en-US" sz="1400" b="1" dirty="0">
-                <a:solidFill>
-                  <a:srgbClr val="3C6FC3"/>
-                </a:solidFill>
-                <a:latin typeface="Georgia" pitchFamily="34" charset="0"/>
-                <a:ea typeface="Georgia" pitchFamily="34" charset="-122"/>
-                <a:cs typeface="Georgia" pitchFamily="34" charset="-120"/>
-              </a:rPr>
-              <a:t>02</a:t>
-            </a:r>
-            <a:endParaRPr lang="en-US" sz="1400" dirty="0"/>
-          </a:p>
-        </p:txBody>
-      </p:sp>
-      <p:sp>
-        <p:nvSpPr>
-          <p:cNvPr id="13" name="Text 11"/>
-          <p:cNvSpPr/>
-          <p:nvPr/>
-        </p:nvSpPr>
-        <p:spPr>
-          <a:xfrm>
-            <a:off x="2496312" y="2487168"/>
-            <a:ext cx="1545336" cy="841248"/>
-          </a:xfrm>
-          <a:prstGeom prst="rect">
-            <a:avLst/>
-          </a:prstGeom>
-          <a:noFill/>
-          <a:ln/>
-        </p:spPr>
-        <p:txBody>
-          <a:bodyPr wrap="square" lIns="0" tIns="0" rIns="0" bIns="0" rtlCol="0" anchor="t"/>
-          <a:lstStyle/>
-          <a:p>
-            <a:pPr algn="ctr" indent="0" marL="0">
-              <a:lnSpc>
-                <a:spcPts val="1500"/>
-              </a:lnSpc>
-              <a:buNone/>
-            </a:pPr>
-            <a:r>
-              <a:rPr lang="en-US" sz="1150" dirty="0">
-                <a:solidFill>
-                  <a:srgbClr val="FFFFFF"/>
-                </a:solidFill>
-                <a:latin typeface="Calibri" pitchFamily="34" charset="0"/>
-                <a:ea typeface="Calibri" pitchFamily="34" charset="-122"/>
-                <a:cs typeface="Calibri" pitchFamily="34" charset="-120"/>
-              </a:rPr>
-              <a:t>Compréhension</a:t>
-            </a:r>
-            <a:endParaRPr lang="en-US" sz="1150" dirty="0"/>
-          </a:p>
-          <a:p>
-            <a:pPr algn="ctr" indent="0" marL="0">
-              <a:lnSpc>
-                <a:spcPts val="1500"/>
-              </a:lnSpc>
-              <a:buNone/>
-            </a:pPr>
-            <a:r>
-              <a:rPr lang="en-US" sz="1150" dirty="0">
-                <a:solidFill>
-                  <a:srgbClr val="FFFFFF"/>
-                </a:solidFill>
-                <a:latin typeface="Calibri" pitchFamily="34" charset="0"/>
-                <a:ea typeface="Calibri" pitchFamily="34" charset="-122"/>
-                <a:cs typeface="Calibri" pitchFamily="34" charset="-120"/>
-              </a:rPr>
-              <a:t>des données</a:t>
-            </a:r>
-            <a:endParaRPr lang="en-US" sz="1150" dirty="0"/>
-          </a:p>
-        </p:txBody>
-      </p:sp>
-      <p:sp>
-        <p:nvSpPr>
-          <p:cNvPr id="14" name="Shape 12"/>
-          <p:cNvSpPr/>
-          <p:nvPr/>
-        </p:nvSpPr>
-        <p:spPr>
-          <a:xfrm>
-            <a:off x="4279392" y="2011680"/>
-            <a:ext cx="1691640" cy="1417320"/>
-          </a:xfrm>
-          <a:prstGeom prst="roundRect">
-            <a:avLst>
-              <a:gd name="adj" fmla="val 5161"/>
-            </a:avLst>
-          </a:prstGeom>
-          <a:solidFill>
-            <a:srgbClr val="0A2558"/>
-          </a:solidFill>
-          <a:ln w="12700">
-            <a:solidFill>
-              <a:srgbClr val="0A2558"/>
-            </a:solidFill>
-            <a:prstDash val="solid"/>
-          </a:ln>
-        </p:spPr>
-      </p:sp>
-      <p:sp>
-        <p:nvSpPr>
-          <p:cNvPr id="15" name="Text 13"/>
-          <p:cNvSpPr/>
-          <p:nvPr/>
-        </p:nvSpPr>
-        <p:spPr>
-          <a:xfrm>
-            <a:off x="4279392" y="2139696"/>
-            <a:ext cx="1691640" cy="310896"/>
-          </a:xfrm>
-          <a:prstGeom prst="rect">
-            <a:avLst/>
-          </a:prstGeom>
-          <a:noFill/>
-          <a:ln/>
-        </p:spPr>
-        <p:txBody>
-          <a:bodyPr wrap="square" lIns="0" tIns="0" rIns="0" bIns="0" rtlCol="0" anchor="ctr"/>
-          <a:lstStyle/>
-          <a:p>
-            <a:pPr algn="ctr" indent="0" marL="0">
-              <a:buNone/>
-            </a:pPr>
-            <a:r>
-              <a:rPr lang="en-US" sz="1400" b="1" dirty="0">
-                <a:solidFill>
-                  <a:srgbClr val="3C6FC3"/>
-                </a:solidFill>
-                <a:latin typeface="Georgia" pitchFamily="34" charset="0"/>
-                <a:ea typeface="Georgia" pitchFamily="34" charset="-122"/>
-                <a:cs typeface="Georgia" pitchFamily="34" charset="-120"/>
-              </a:rPr>
-              <a:t>03</a:t>
-            </a:r>
-            <a:endParaRPr lang="en-US" sz="1400" dirty="0"/>
-          </a:p>
-        </p:txBody>
-      </p:sp>
-      <p:sp>
-        <p:nvSpPr>
-          <p:cNvPr id="16" name="Text 14"/>
-          <p:cNvSpPr/>
-          <p:nvPr/>
-        </p:nvSpPr>
-        <p:spPr>
-          <a:xfrm>
-            <a:off x="4352544" y="2487168"/>
-            <a:ext cx="1545336" cy="841248"/>
-          </a:xfrm>
-          <a:prstGeom prst="rect">
-            <a:avLst/>
-          </a:prstGeom>
-          <a:noFill/>
-          <a:ln/>
-        </p:spPr>
-        <p:txBody>
-          <a:bodyPr wrap="square" lIns="0" tIns="0" rIns="0" bIns="0" rtlCol="0" anchor="t"/>
-          <a:lstStyle/>
-          <a:p>
-            <a:pPr algn="ctr" indent="0" marL="0">
-              <a:lnSpc>
-                <a:spcPts val="1500"/>
-              </a:lnSpc>
-              <a:buNone/>
-            </a:pPr>
-            <a:r>
-              <a:rPr lang="en-US" sz="1150" dirty="0">
-                <a:solidFill>
-                  <a:srgbClr val="FFFFFF"/>
-                </a:solidFill>
-                <a:latin typeface="Calibri" pitchFamily="34" charset="0"/>
-                <a:ea typeface="Calibri" pitchFamily="34" charset="-122"/>
-                <a:cs typeface="Calibri" pitchFamily="34" charset="-120"/>
-              </a:rPr>
-              <a:t>Préparation</a:t>
-            </a:r>
-            <a:endParaRPr lang="en-US" sz="1150" dirty="0"/>
-          </a:p>
-          <a:p>
-            <a:pPr algn="ctr" indent="0" marL="0">
-              <a:lnSpc>
-                <a:spcPts val="1500"/>
-              </a:lnSpc>
-              <a:buNone/>
-            </a:pPr>
-            <a:r>
-              <a:rPr lang="en-US" sz="1150" dirty="0">
-                <a:solidFill>
-                  <a:srgbClr val="FFFFFF"/>
-                </a:solidFill>
-                <a:latin typeface="Calibri" pitchFamily="34" charset="0"/>
-                <a:ea typeface="Calibri" pitchFamily="34" charset="-122"/>
-                <a:cs typeface="Calibri" pitchFamily="34" charset="-120"/>
-              </a:rPr>
-              <a:t>des données</a:t>
-            </a:r>
-            <a:endParaRPr lang="en-US" sz="1150" dirty="0"/>
-          </a:p>
-        </p:txBody>
-      </p:sp>
-      <p:sp>
-        <p:nvSpPr>
-          <p:cNvPr id="17" name="Shape 15"/>
-          <p:cNvSpPr/>
-          <p:nvPr/>
-        </p:nvSpPr>
-        <p:spPr>
-          <a:xfrm>
-            <a:off x="6135624" y="2011680"/>
-            <a:ext cx="1691640" cy="1417320"/>
-          </a:xfrm>
-          <a:prstGeom prst="roundRect">
-            <a:avLst>
-              <a:gd name="adj" fmla="val 5161"/>
-            </a:avLst>
-          </a:prstGeom>
-          <a:solidFill>
-            <a:srgbClr val="1D4EA0"/>
-          </a:solidFill>
-          <a:ln w="12700">
-            <a:solidFill>
-              <a:srgbClr val="1D4EA0"/>
-            </a:solidFill>
-            <a:prstDash val="solid"/>
-          </a:ln>
-        </p:spPr>
-      </p:sp>
-      <p:sp>
-        <p:nvSpPr>
-          <p:cNvPr id="18" name="Text 16"/>
-          <p:cNvSpPr/>
-          <p:nvPr/>
-        </p:nvSpPr>
-        <p:spPr>
-          <a:xfrm>
-            <a:off x="6135624" y="2139696"/>
-            <a:ext cx="1691640" cy="310896"/>
-          </a:xfrm>
-          <a:prstGeom prst="rect">
-            <a:avLst/>
-          </a:prstGeom>
-          <a:noFill/>
-          <a:ln/>
-        </p:spPr>
-        <p:txBody>
-          <a:bodyPr wrap="square" lIns="0" tIns="0" rIns="0" bIns="0" rtlCol="0" anchor="ctr"/>
-          <a:lstStyle/>
-          <a:p>
-            <a:pPr algn="ctr" indent="0" marL="0">
-              <a:buNone/>
-            </a:pPr>
-            <a:r>
-              <a:rPr lang="en-US" sz="1400" b="1" dirty="0">
-                <a:solidFill>
-                  <a:srgbClr val="3C6FC3"/>
-                </a:solidFill>
-                <a:latin typeface="Georgia" pitchFamily="34" charset="0"/>
-                <a:ea typeface="Georgia" pitchFamily="34" charset="-122"/>
-                <a:cs typeface="Georgia" pitchFamily="34" charset="-120"/>
-              </a:rPr>
-              <a:t>04</a:t>
-            </a:r>
-            <a:endParaRPr lang="en-US" sz="1400" dirty="0"/>
-          </a:p>
-        </p:txBody>
-      </p:sp>
-      <p:sp>
-        <p:nvSpPr>
-          <p:cNvPr id="19" name="Text 17"/>
-          <p:cNvSpPr/>
-          <p:nvPr/>
-        </p:nvSpPr>
-        <p:spPr>
-          <a:xfrm>
-            <a:off x="6208776" y="2487168"/>
-            <a:ext cx="1545336" cy="841248"/>
-          </a:xfrm>
-          <a:prstGeom prst="rect">
-            <a:avLst/>
-          </a:prstGeom>
-          <a:noFill/>
-          <a:ln/>
-        </p:spPr>
-        <p:txBody>
-          <a:bodyPr wrap="square" lIns="0" tIns="0" rIns="0" bIns="0" rtlCol="0" anchor="t"/>
-          <a:lstStyle/>
-          <a:p>
-            <a:pPr algn="ctr" indent="0" marL="0">
-              <a:lnSpc>
-                <a:spcPts val="1500"/>
-              </a:lnSpc>
-              <a:buNone/>
-            </a:pPr>
-            <a:r>
-              <a:rPr lang="en-US" sz="1150" dirty="0">
-                <a:solidFill>
-                  <a:srgbClr val="FFFFFF"/>
-                </a:solidFill>
-                <a:latin typeface="Calibri" pitchFamily="34" charset="0"/>
-                <a:ea typeface="Calibri" pitchFamily="34" charset="-122"/>
-                <a:cs typeface="Calibri" pitchFamily="34" charset="-120"/>
-              </a:rPr>
-              <a:t>Modélisation</a:t>
-            </a:r>
-            <a:endParaRPr lang="en-US" sz="1150" dirty="0"/>
-          </a:p>
-        </p:txBody>
-      </p:sp>
-      <p:sp>
-        <p:nvSpPr>
-          <p:cNvPr id="20" name="Shape 18"/>
-          <p:cNvSpPr/>
-          <p:nvPr/>
-        </p:nvSpPr>
-        <p:spPr>
-          <a:xfrm>
-            <a:off x="7991856" y="2011680"/>
-            <a:ext cx="1691640" cy="1417320"/>
-          </a:xfrm>
-          <a:prstGeom prst="roundRect">
-            <a:avLst>
-              <a:gd name="adj" fmla="val 5161"/>
-            </a:avLst>
-          </a:prstGeom>
-          <a:solidFill>
-            <a:srgbClr val="0A2558"/>
-          </a:solidFill>
-          <a:ln w="12700">
-            <a:solidFill>
-              <a:srgbClr val="0A2558"/>
-            </a:solidFill>
-            <a:prstDash val="solid"/>
-          </a:ln>
-        </p:spPr>
-      </p:sp>
-      <p:sp>
-        <p:nvSpPr>
-          <p:cNvPr id="21" name="Text 19"/>
-          <p:cNvSpPr/>
-          <p:nvPr/>
-        </p:nvSpPr>
-        <p:spPr>
-          <a:xfrm>
-            <a:off x="7991856" y="2139696"/>
-            <a:ext cx="1691640" cy="310896"/>
-          </a:xfrm>
-          <a:prstGeom prst="rect">
-            <a:avLst/>
-          </a:prstGeom>
-          <a:noFill/>
-          <a:ln/>
-        </p:spPr>
-        <p:txBody>
-          <a:bodyPr wrap="square" lIns="0" tIns="0" rIns="0" bIns="0" rtlCol="0" anchor="ctr"/>
-          <a:lstStyle/>
-          <a:p>
-            <a:pPr algn="ctr" indent="0" marL="0">
-              <a:buNone/>
-            </a:pPr>
-            <a:r>
-              <a:rPr lang="en-US" sz="1400" b="1" dirty="0">
-                <a:solidFill>
-                  <a:srgbClr val="3C6FC3"/>
-                </a:solidFill>
-                <a:latin typeface="Georgia" pitchFamily="34" charset="0"/>
-                <a:ea typeface="Georgia" pitchFamily="34" charset="-122"/>
-                <a:cs typeface="Georgia" pitchFamily="34" charset="-120"/>
-              </a:rPr>
-              <a:t>05</a:t>
-            </a:r>
-            <a:endParaRPr lang="en-US" sz="1400" dirty="0"/>
-          </a:p>
-        </p:txBody>
-      </p:sp>
-      <p:sp>
-        <p:nvSpPr>
-          <p:cNvPr id="22" name="Text 20"/>
-          <p:cNvSpPr/>
-          <p:nvPr/>
-        </p:nvSpPr>
-        <p:spPr>
-          <a:xfrm>
-            <a:off x="8065008" y="2487168"/>
-            <a:ext cx="1545336" cy="841248"/>
-          </a:xfrm>
-          <a:prstGeom prst="rect">
-            <a:avLst/>
-          </a:prstGeom>
-          <a:noFill/>
-          <a:ln/>
-        </p:spPr>
-        <p:txBody>
-          <a:bodyPr wrap="square" lIns="0" tIns="0" rIns="0" bIns="0" rtlCol="0" anchor="t"/>
-          <a:lstStyle/>
-          <a:p>
-            <a:pPr algn="ctr" indent="0" marL="0">
-              <a:lnSpc>
-                <a:spcPts val="1500"/>
-              </a:lnSpc>
-              <a:buNone/>
-            </a:pPr>
-            <a:r>
-              <a:rPr lang="en-US" sz="1150" dirty="0">
-                <a:solidFill>
-                  <a:srgbClr val="FFFFFF"/>
-                </a:solidFill>
-                <a:latin typeface="Calibri" pitchFamily="34" charset="0"/>
-                <a:ea typeface="Calibri" pitchFamily="34" charset="-122"/>
-                <a:cs typeface="Calibri" pitchFamily="34" charset="-120"/>
-              </a:rPr>
-              <a:t>Évaluation</a:t>
-            </a:r>
-            <a:endParaRPr lang="en-US" sz="1150" dirty="0"/>
-          </a:p>
-        </p:txBody>
-      </p:sp>
-      <p:sp>
-        <p:nvSpPr>
-          <p:cNvPr id="23" name="Shape 21"/>
-          <p:cNvSpPr/>
-          <p:nvPr/>
-        </p:nvSpPr>
-        <p:spPr>
-          <a:xfrm>
-            <a:off x="9848088" y="2011680"/>
-            <a:ext cx="1691640" cy="1417320"/>
-          </a:xfrm>
-          <a:prstGeom prst="roundRect">
-            <a:avLst>
-              <a:gd name="adj" fmla="val 5161"/>
-            </a:avLst>
-          </a:prstGeom>
-          <a:solidFill>
-            <a:srgbClr val="1D4EA0"/>
-          </a:solidFill>
-          <a:ln w="12700">
-            <a:solidFill>
-              <a:srgbClr val="1D4EA0"/>
-            </a:solidFill>
-            <a:prstDash val="solid"/>
-          </a:ln>
-        </p:spPr>
-      </p:sp>
-      <p:sp>
-        <p:nvSpPr>
-          <p:cNvPr id="24" name="Text 22"/>
-          <p:cNvSpPr/>
-          <p:nvPr/>
-        </p:nvSpPr>
-        <p:spPr>
-          <a:xfrm>
-            <a:off x="9848088" y="2139696"/>
-            <a:ext cx="1691640" cy="310896"/>
-          </a:xfrm>
-          <a:prstGeom prst="rect">
-            <a:avLst/>
-          </a:prstGeom>
-          <a:noFill/>
-          <a:ln/>
-        </p:spPr>
-        <p:txBody>
-          <a:bodyPr wrap="square" lIns="0" tIns="0" rIns="0" bIns="0" rtlCol="0" anchor="ctr"/>
-          <a:lstStyle/>
-          <a:p>
-            <a:pPr algn="ctr" indent="0" marL="0">
-              <a:buNone/>
-            </a:pPr>
-            <a:r>
-              <a:rPr lang="en-US" sz="1400" b="1" dirty="0">
-                <a:solidFill>
-                  <a:srgbClr val="3C6FC3"/>
-                </a:solidFill>
-                <a:latin typeface="Georgia" pitchFamily="34" charset="0"/>
-                <a:ea typeface="Georgia" pitchFamily="34" charset="-122"/>
-                <a:cs typeface="Georgia" pitchFamily="34" charset="-120"/>
-              </a:rPr>
-              <a:t>06</a:t>
-            </a:r>
-            <a:endParaRPr lang="en-US" sz="1400" dirty="0"/>
-          </a:p>
-        </p:txBody>
-      </p:sp>
-      <p:sp>
-        <p:nvSpPr>
-          <p:cNvPr id="25" name="Text 23"/>
-          <p:cNvSpPr/>
-          <p:nvPr/>
-        </p:nvSpPr>
-        <p:spPr>
-          <a:xfrm>
-            <a:off x="9921240" y="2487168"/>
-            <a:ext cx="1545336" cy="841248"/>
-          </a:xfrm>
-          <a:prstGeom prst="rect">
-            <a:avLst/>
-          </a:prstGeom>
-          <a:noFill/>
-          <a:ln/>
-        </p:spPr>
-        <p:txBody>
-          <a:bodyPr wrap="square" lIns="0" tIns="0" rIns="0" bIns="0" rtlCol="0" anchor="t"/>
-          <a:lstStyle/>
-          <a:p>
-            <a:pPr algn="ctr" indent="0" marL="0">
-              <a:lnSpc>
-                <a:spcPts val="1500"/>
-              </a:lnSpc>
-              <a:buNone/>
-            </a:pPr>
-            <a:r>
-              <a:rPr lang="en-US" sz="1150" dirty="0">
-                <a:solidFill>
-                  <a:srgbClr val="FFFFFF"/>
-                </a:solidFill>
-                <a:latin typeface="Calibri" pitchFamily="34" charset="0"/>
-                <a:ea typeface="Calibri" pitchFamily="34" charset="-122"/>
-                <a:cs typeface="Calibri" pitchFamily="34" charset="-120"/>
-              </a:rPr>
-              <a:t>Déploiement</a:t>
-            </a:r>
-            <a:endParaRPr lang="en-US" sz="1150" dirty="0"/>
-          </a:p>
-        </p:txBody>
-      </p:sp>
-      <p:sp>
-        <p:nvSpPr>
-          <p:cNvPr id="26" name="Text 24"/>
-          <p:cNvSpPr/>
-          <p:nvPr/>
-        </p:nvSpPr>
-        <p:spPr>
-          <a:xfrm>
-            <a:off x="566928" y="3703320"/>
-            <a:ext cx="5394960" cy="274320"/>
-          </a:xfrm>
-          <a:prstGeom prst="rect">
-            <a:avLst/>
-          </a:prstGeom>
-          <a:noFill/>
-          <a:ln/>
-        </p:spPr>
-        <p:txBody>
-          <a:bodyPr wrap="square" lIns="0" tIns="0" rIns="0" bIns="0" rtlCol="0" anchor="ctr"/>
-          <a:lstStyle/>
-          <a:p>
-            <a:pPr indent="0" marL="0">
-              <a:buNone/>
-            </a:pPr>
-            <a:r>
-              <a:rPr lang="en-US" sz="1050" b="1" spc="200" kern="0" dirty="0">
-                <a:solidFill>
-                  <a:srgbClr val="3C6FC3"/>
-                </a:solidFill>
-                <a:latin typeface="Calibri" pitchFamily="34" charset="0"/>
-                <a:ea typeface="Calibri" pitchFamily="34" charset="-122"/>
-                <a:cs typeface="Calibri" pitchFamily="34" charset="-120"/>
-              </a:rPr>
               <a:t>POURQUOI CRISP-DM ?</a:t>
             </a:r>
             <a:endParaRPr lang="en-US" sz="1050" dirty="0"/>
@@ -5557,13 +4873,13 @@
       </p:sp>
       <p:sp>
         <p:nvSpPr>
-          <p:cNvPr id="27" name="Shape 25"/>
-          <p:cNvSpPr/>
-          <p:nvPr/>
-        </p:nvSpPr>
-        <p:spPr>
-          <a:xfrm>
-            <a:off x="566928" y="4169664"/>
+          <p:cNvPr id="10" name="Shape 7"/>
+          <p:cNvSpPr/>
+          <p:nvPr/>
+        </p:nvSpPr>
+        <p:spPr>
+          <a:xfrm>
+            <a:off x="6720840" y="2286000"/>
             <a:ext cx="109728" cy="109728"/>
           </a:xfrm>
           <a:prstGeom prst="ellipse">
@@ -5582,14 +4898,14 @@
       </p:sp>
       <p:sp>
         <p:nvSpPr>
-          <p:cNvPr id="28" name="Text 26"/>
-          <p:cNvSpPr/>
-          <p:nvPr/>
-        </p:nvSpPr>
-        <p:spPr>
-          <a:xfrm>
-            <a:off x="841248" y="4023360"/>
-            <a:ext cx="5120640" cy="420624"/>
+          <p:cNvPr id="11" name="Text 8"/>
+          <p:cNvSpPr/>
+          <p:nvPr/>
+        </p:nvSpPr>
+        <p:spPr>
+          <a:xfrm>
+            <a:off x="6995160" y="2139696"/>
+            <a:ext cx="4663440" cy="420624"/>
           </a:xfrm>
           <a:prstGeom prst="rect">
             <a:avLst/>
@@ -5605,7 +4921,7 @@
               <a:buNone/>
             </a:pPr>
             <a:r>
-              <a:rPr lang="en-US" sz="1250" dirty="0">
+              <a:rPr lang="en-US" sz="1200" dirty="0">
                 <a:solidFill>
                   <a:srgbClr val="1B2A44"/>
                 </a:solidFill>
@@ -5615,19 +4931,19 @@
               </a:rPr>
               <a:t>Méthodologie de référence des projets décisionnels</a:t>
             </a:r>
-            <a:endParaRPr lang="en-US" sz="1250" dirty="0"/>
-          </a:p>
-        </p:txBody>
-      </p:sp>
-      <p:sp>
-        <p:nvSpPr>
-          <p:cNvPr id="29" name="Shape 27"/>
-          <p:cNvSpPr/>
-          <p:nvPr/>
-        </p:nvSpPr>
-        <p:spPr>
-          <a:xfrm>
-            <a:off x="566928" y="4626864"/>
+            <a:endParaRPr lang="en-US" sz="1200" dirty="0"/>
+          </a:p>
+        </p:txBody>
+      </p:sp>
+      <p:sp>
+        <p:nvSpPr>
+          <p:cNvPr id="12" name="Shape 9"/>
+          <p:cNvSpPr/>
+          <p:nvPr/>
+        </p:nvSpPr>
+        <p:spPr>
+          <a:xfrm>
+            <a:off x="6720840" y="2743200"/>
             <a:ext cx="109728" cy="109728"/>
           </a:xfrm>
           <a:prstGeom prst="ellipse">
@@ -5646,14 +4962,14 @@
       </p:sp>
       <p:sp>
         <p:nvSpPr>
-          <p:cNvPr id="30" name="Text 28"/>
-          <p:cNvSpPr/>
-          <p:nvPr/>
-        </p:nvSpPr>
-        <p:spPr>
-          <a:xfrm>
-            <a:off x="841248" y="4480560"/>
-            <a:ext cx="5120640" cy="420624"/>
+          <p:cNvPr id="13" name="Text 10"/>
+          <p:cNvSpPr/>
+          <p:nvPr/>
+        </p:nvSpPr>
+        <p:spPr>
+          <a:xfrm>
+            <a:off x="6995160" y="2596896"/>
+            <a:ext cx="4663440" cy="420624"/>
           </a:xfrm>
           <a:prstGeom prst="rect">
             <a:avLst/>
@@ -5669,7 +4985,7 @@
               <a:buNone/>
             </a:pPr>
             <a:r>
-              <a:rPr lang="en-US" sz="1250" dirty="0">
+              <a:rPr lang="en-US" sz="1200" dirty="0">
                 <a:solidFill>
                   <a:srgbClr val="1B2A44"/>
                 </a:solidFill>
@@ -5679,19 +4995,19 @@
               </a:rPr>
               <a:t>Ses six phases épousent le déroulement réel du projet</a:t>
             </a:r>
-            <a:endParaRPr lang="en-US" sz="1250" dirty="0"/>
-          </a:p>
-        </p:txBody>
-      </p:sp>
-      <p:sp>
-        <p:nvSpPr>
-          <p:cNvPr id="31" name="Shape 29"/>
-          <p:cNvSpPr/>
-          <p:nvPr/>
-        </p:nvSpPr>
-        <p:spPr>
-          <a:xfrm>
-            <a:off x="566928" y="5084064"/>
+            <a:endParaRPr lang="en-US" sz="1200" dirty="0"/>
+          </a:p>
+        </p:txBody>
+      </p:sp>
+      <p:sp>
+        <p:nvSpPr>
+          <p:cNvPr id="14" name="Shape 11"/>
+          <p:cNvSpPr/>
+          <p:nvPr/>
+        </p:nvSpPr>
+        <p:spPr>
+          <a:xfrm>
+            <a:off x="6720840" y="3200400"/>
             <a:ext cx="109728" cy="109728"/>
           </a:xfrm>
           <a:prstGeom prst="ellipse">
@@ -5710,14 +5026,14 @@
       </p:sp>
       <p:sp>
         <p:nvSpPr>
-          <p:cNvPr id="32" name="Text 30"/>
-          <p:cNvSpPr/>
-          <p:nvPr/>
-        </p:nvSpPr>
-        <p:spPr>
-          <a:xfrm>
-            <a:off x="841248" y="4937760"/>
-            <a:ext cx="5120640" cy="420624"/>
+          <p:cNvPr id="15" name="Text 12"/>
+          <p:cNvSpPr/>
+          <p:nvPr/>
+        </p:nvSpPr>
+        <p:spPr>
+          <a:xfrm>
+            <a:off x="6995160" y="3054096"/>
+            <a:ext cx="4663440" cy="420624"/>
           </a:xfrm>
           <a:prstGeom prst="rect">
             <a:avLst/>
@@ -5733,7 +5049,7 @@
               <a:buNone/>
             </a:pPr>
             <a:r>
-              <a:rPr lang="en-US" sz="1250" dirty="0">
+              <a:rPr lang="en-US" sz="1200" dirty="0">
                 <a:solidFill>
                   <a:srgbClr val="1B2A44"/>
                 </a:solidFill>
@@ -5743,24 +5059,88 @@
               </a:rPr>
               <a:t>Pratiques agiles conservées : itérations et validations</a:t>
             </a:r>
-            <a:endParaRPr lang="en-US" sz="1250" dirty="0"/>
-          </a:p>
-        </p:txBody>
-      </p:sp>
-      <p:sp>
-        <p:nvSpPr>
-          <p:cNvPr id="33" name="Shape 31"/>
-          <p:cNvSpPr/>
-          <p:nvPr/>
-        </p:nvSpPr>
-        <p:spPr>
-          <a:xfrm>
-            <a:off x="6537960" y="3950208"/>
-            <a:ext cx="5120640" cy="1783080"/>
+            <a:endParaRPr lang="en-US" sz="1200" dirty="0"/>
+          </a:p>
+        </p:txBody>
+      </p:sp>
+      <p:sp>
+        <p:nvSpPr>
+          <p:cNvPr id="16" name="Shape 13"/>
+          <p:cNvSpPr/>
+          <p:nvPr/>
+        </p:nvSpPr>
+        <p:spPr>
+          <a:xfrm>
+            <a:off x="6720840" y="3657600"/>
+            <a:ext cx="109728" cy="109728"/>
+          </a:xfrm>
+          <a:prstGeom prst="ellipse">
+            <a:avLst/>
+          </a:prstGeom>
+          <a:solidFill>
+            <a:srgbClr val="3C6FC3"/>
+          </a:solidFill>
+          <a:ln w="12700">
+            <a:solidFill>
+              <a:srgbClr val="3C6FC3"/>
+            </a:solidFill>
+            <a:prstDash val="solid"/>
+          </a:ln>
+        </p:spPr>
+      </p:sp>
+      <p:sp>
+        <p:nvSpPr>
+          <p:cNvPr id="17" name="Text 14"/>
+          <p:cNvSpPr/>
+          <p:nvPr/>
+        </p:nvSpPr>
+        <p:spPr>
+          <a:xfrm>
+            <a:off x="6995160" y="3511296"/>
+            <a:ext cx="4663440" cy="420624"/>
+          </a:xfrm>
+          <a:prstGeom prst="rect">
+            <a:avLst/>
+          </a:prstGeom>
+          <a:noFill/>
+          <a:ln/>
+        </p:spPr>
+        <p:txBody>
+          <a:bodyPr wrap="square" lIns="0" tIns="0" rIns="0" bIns="0" rtlCol="0" anchor="ctr"/>
+          <a:lstStyle/>
+          <a:p>
+            <a:pPr indent="0" marL="0">
+              <a:buNone/>
+            </a:pPr>
+            <a:r>
+              <a:rPr lang="en-US" sz="1200" dirty="0">
+                <a:solidFill>
+                  <a:srgbClr val="1B2A44"/>
+                </a:solidFill>
+                <a:latin typeface="Calibri" pitchFamily="34" charset="0"/>
+                <a:ea typeface="Calibri" pitchFamily="34" charset="-122"/>
+                <a:cs typeface="Calibri" pitchFamily="34" charset="-120"/>
+              </a:rPr>
+              <a:t>Scrum ne couvre pas l'analyse et la valorisation des données</a:t>
+            </a:r>
+            <a:endParaRPr lang="en-US" sz="1200" dirty="0"/>
+          </a:p>
+        </p:txBody>
+      </p:sp>
+      <p:sp>
+        <p:nvSpPr>
+          <p:cNvPr id="18" name="Shape 15"/>
+          <p:cNvSpPr/>
+          <p:nvPr/>
+        </p:nvSpPr>
+        <p:spPr>
+          <a:xfrm>
+            <a:off x="6720840" y="4224528"/>
+            <a:ext cx="4937760" cy="1874520"/>
           </a:xfrm>
           <a:prstGeom prst="roundRect">
             <a:avLst>
-              <a:gd name="adj" fmla="val 3077"/>
+              <a:gd name="adj" fmla="val 2927"/>
             </a:avLst>
           </a:prstGeom>
           <a:solidFill>
@@ -5776,14 +5156,34 @@
       </p:sp>
       <p:sp>
         <p:nvSpPr>
-          <p:cNvPr id="34" name="Text 32"/>
-          <p:cNvSpPr/>
-          <p:nvPr/>
-        </p:nvSpPr>
-        <p:spPr>
-          <a:xfrm>
-            <a:off x="6784848" y="4114800"/>
-            <a:ext cx="4663440" cy="329184"/>
+          <p:cNvPr id="19" name="Shape 16"/>
+          <p:cNvSpPr/>
+          <p:nvPr/>
+        </p:nvSpPr>
+        <p:spPr>
+          <a:xfrm>
+            <a:off x="6720840" y="4224528"/>
+            <a:ext cx="4937760" cy="73152"/>
+          </a:xfrm>
+          <a:prstGeom prst="rect">
+            <a:avLst/>
+          </a:prstGeom>
+          <a:solidFill>
+            <a:srgbClr val="3C6FC3"/>
+          </a:solidFill>
+          <a:ln/>
+        </p:spPr>
+      </p:sp>
+      <p:sp>
+        <p:nvSpPr>
+          <p:cNvPr id="20" name="Text 17"/>
+          <p:cNvSpPr/>
+          <p:nvPr/>
+        </p:nvSpPr>
+        <p:spPr>
+          <a:xfrm>
+            <a:off x="6967728" y="4407408"/>
+            <a:ext cx="4480560" cy="329184"/>
           </a:xfrm>
           <a:prstGeom prst="rect">
             <a:avLst/>
@@ -5815,14 +5215,14 @@
       </p:sp>
       <p:sp>
         <p:nvSpPr>
-          <p:cNvPr id="35" name="Text 33"/>
-          <p:cNvSpPr/>
-          <p:nvPr/>
-        </p:nvSpPr>
-        <p:spPr>
-          <a:xfrm>
-            <a:off x="6784848" y="4480560"/>
-            <a:ext cx="4663440" cy="1143000"/>
+          <p:cNvPr id="21" name="Text 18"/>
+          <p:cNvSpPr/>
+          <p:nvPr/>
+        </p:nvSpPr>
+        <p:spPr>
+          <a:xfrm>
+            <a:off x="6967728" y="4791456"/>
+            <a:ext cx="4480560" cy="1188720"/>
           </a:xfrm>
           <a:prstGeom prst="rect">
             <a:avLst/>

</xml_diff>

<commit_message>
Slide de demonstration : uniquement l'application web
La slide annoncait "application web, tableau de bord embarque et rapport
Power BI" alors que la demonstration en direct ne porte que sur
l'application web. Le titre et le contenu sont corriges, avec le parcours
reellement presente en quatre etapes (authentification, gestion du reseau,
pointage, tableau de bord) et une mention precisant que les rapports
Power BI ont ete montres en images dans la partie precedente.

Co-Authored-By: Claude Opus 4.8 <noreply@anthropic.com>
Claude-Session: https://claude.ai/code/session_01XrCEv79rD628gYBfC2XWx6
</commit_message>
<xml_diff>
--- a/presentation/Soutenance_PFE_Oussema_Korbosli.pptx
+++ b/presentation/Soutenance_PFE_Oussema_Korbosli.pptx
@@ -22573,7 +22573,7 @@
         </p:nvSpPr>
         <p:spPr>
           <a:xfrm>
-            <a:off x="566928" y="2514600"/>
+            <a:off x="566928" y="1600200"/>
             <a:ext cx="8229600" cy="329184"/>
           </a:xfrm>
           <a:prstGeom prst="rect">
@@ -22612,7 +22612,7 @@
         </p:nvSpPr>
         <p:spPr>
           <a:xfrm>
-            <a:off x="566928" y="2926080"/>
+            <a:off x="566928" y="1993392"/>
             <a:ext cx="10058400" cy="731520"/>
           </a:xfrm>
           <a:prstGeom prst="rect">
@@ -22637,7 +22637,7 @@
                 <a:ea typeface="Georgia" pitchFamily="34" charset="-122"/>
                 <a:cs typeface="Georgia" pitchFamily="34" charset="-120"/>
               </a:rPr>
-              <a:t>Démonstration en direct</a:t>
+              <a:t>Démonstration de l'application web</a:t>
             </a:r>
             <a:endParaRPr lang="en-US" sz="3400" dirty="0"/>
           </a:p>
@@ -22645,14 +22645,34 @@
       </p:sp>
       <p:sp>
         <p:nvSpPr>
-          <p:cNvPr id="6" name="Text 4"/>
-          <p:cNvSpPr/>
-          <p:nvPr/>
-        </p:nvSpPr>
-        <p:spPr>
-          <a:xfrm>
-            <a:off x="566928" y="3749040"/>
-            <a:ext cx="10058400" cy="365760"/>
+          <p:cNvPr id="6" name="Shape 4"/>
+          <p:cNvSpPr/>
+          <p:nvPr/>
+        </p:nvSpPr>
+        <p:spPr>
+          <a:xfrm>
+            <a:off x="566928" y="2816352"/>
+            <a:ext cx="1234440" cy="27432"/>
+          </a:xfrm>
+          <a:prstGeom prst="rect">
+            <a:avLst/>
+          </a:prstGeom>
+          <a:solidFill>
+            <a:srgbClr val="3C6FC3"/>
+          </a:solidFill>
+          <a:ln/>
+        </p:spPr>
+      </p:sp>
+      <p:sp>
+        <p:nvSpPr>
+          <p:cNvPr id="7" name="Text 5"/>
+          <p:cNvSpPr/>
+          <p:nvPr/>
+        </p:nvSpPr>
+        <p:spPr>
+          <a:xfrm>
+            <a:off x="566928" y="3090672"/>
+            <a:ext cx="10058400" cy="329184"/>
           </a:xfrm>
           <a:prstGeom prst="rect">
             <a:avLst/>
@@ -22668,7 +22688,7 @@
               <a:buNone/>
             </a:pPr>
             <a:r>
-              <a:rPr lang="en-US" sz="1500" dirty="0">
+              <a:rPr lang="en-US" sz="1400" dirty="0">
                 <a:solidFill>
                   <a:srgbClr val="CBD8EE"/>
                 </a:solidFill>
@@ -22676,31 +22696,738 @@
                 <a:ea typeface="Calibri" pitchFamily="34" charset="-122"/>
                 <a:cs typeface="Calibri" pitchFamily="34" charset="-120"/>
               </a:rPr>
-              <a:t>Application web · tableau de bord embarqué · rapport Power BI</a:t>
-            </a:r>
-            <a:endParaRPr lang="en-US" sz="1500" dirty="0"/>
-          </a:p>
-        </p:txBody>
-      </p:sp>
-      <p:sp>
-        <p:nvSpPr>
-          <p:cNvPr id="7" name="Shape 5"/>
-          <p:cNvSpPr/>
-          <p:nvPr/>
-        </p:nvSpPr>
-        <p:spPr>
-          <a:xfrm>
-            <a:off x="566928" y="4343400"/>
-            <a:ext cx="1234440" cy="27432"/>
-          </a:xfrm>
-          <a:prstGeom prst="rect">
-            <a:avLst/>
-          </a:prstGeom>
-          <a:solidFill>
-            <a:srgbClr val="3C6FC3"/>
-          </a:solidFill>
-          <a:ln/>
-        </p:spPr>
+              <a:t>Parcours présenté en direct :</a:t>
+            </a:r>
+            <a:endParaRPr lang="en-US" sz="1400" dirty="0"/>
+          </a:p>
+        </p:txBody>
+      </p:sp>
+      <p:sp>
+        <p:nvSpPr>
+          <p:cNvPr id="8" name="Shape 6"/>
+          <p:cNvSpPr/>
+          <p:nvPr/>
+        </p:nvSpPr>
+        <p:spPr>
+          <a:xfrm>
+            <a:off x="566928" y="3611880"/>
+            <a:ext cx="2468880" cy="1600200"/>
+          </a:xfrm>
+          <a:prstGeom prst="roundRect">
+            <a:avLst>
+              <a:gd name="adj" fmla="val 4571"/>
+            </a:avLst>
+          </a:prstGeom>
+          <a:solidFill>
+            <a:srgbClr val="1D4EA0"/>
+          </a:solidFill>
+          <a:ln w="12700">
+            <a:solidFill>
+              <a:srgbClr val="1D4EA0"/>
+            </a:solidFill>
+            <a:prstDash val="solid"/>
+          </a:ln>
+        </p:spPr>
+      </p:sp>
+      <p:sp>
+        <p:nvSpPr>
+          <p:cNvPr id="9" name="Shape 7"/>
+          <p:cNvSpPr/>
+          <p:nvPr/>
+        </p:nvSpPr>
+        <p:spPr>
+          <a:xfrm>
+            <a:off x="1600200" y="3803904"/>
+            <a:ext cx="402336" cy="402336"/>
+          </a:xfrm>
+          <a:prstGeom prst="ellipse">
+            <a:avLst/>
+          </a:prstGeom>
+          <a:solidFill>
+            <a:srgbClr val="0A2558"/>
+          </a:solidFill>
+          <a:ln w="12700">
+            <a:solidFill>
+              <a:srgbClr val="0A2558"/>
+            </a:solidFill>
+            <a:prstDash val="solid"/>
+          </a:ln>
+        </p:spPr>
+      </p:sp>
+      <p:sp>
+        <p:nvSpPr>
+          <p:cNvPr id="10" name="Text 8"/>
+          <p:cNvSpPr/>
+          <p:nvPr/>
+        </p:nvSpPr>
+        <p:spPr>
+          <a:xfrm>
+            <a:off x="1600200" y="3803904"/>
+            <a:ext cx="402336" cy="402336"/>
+          </a:xfrm>
+          <a:prstGeom prst="rect">
+            <a:avLst/>
+          </a:prstGeom>
+          <a:noFill/>
+          <a:ln/>
+        </p:spPr>
+        <p:txBody>
+          <a:bodyPr wrap="square" lIns="0" tIns="0" rIns="0" bIns="0" rtlCol="0" anchor="ctr"/>
+          <a:lstStyle/>
+          <a:p>
+            <a:pPr algn="ctr" indent="0" marL="0">
+              <a:buNone/>
+            </a:pPr>
+            <a:r>
+              <a:rPr lang="en-US" sz="1300" b="1" dirty="0">
+                <a:solidFill>
+                  <a:srgbClr val="FFFFFF"/>
+                </a:solidFill>
+                <a:latin typeface="Georgia" pitchFamily="34" charset="0"/>
+                <a:ea typeface="Georgia" pitchFamily="34" charset="-122"/>
+                <a:cs typeface="Georgia" pitchFamily="34" charset="-120"/>
+              </a:rPr>
+              <a:t>1</a:t>
+            </a:r>
+            <a:endParaRPr lang="en-US" sz="1300" dirty="0"/>
+          </a:p>
+        </p:txBody>
+      </p:sp>
+      <p:sp>
+        <p:nvSpPr>
+          <p:cNvPr id="11" name="Text 9"/>
+          <p:cNvSpPr/>
+          <p:nvPr/>
+        </p:nvSpPr>
+        <p:spPr>
+          <a:xfrm>
+            <a:off x="713232" y="4297680"/>
+            <a:ext cx="2176272" cy="365760"/>
+          </a:xfrm>
+          <a:prstGeom prst="rect">
+            <a:avLst/>
+          </a:prstGeom>
+          <a:noFill/>
+          <a:ln/>
+        </p:spPr>
+        <p:txBody>
+          <a:bodyPr wrap="square" lIns="0" tIns="0" rIns="0" bIns="0" rtlCol="0" anchor="ctr"/>
+          <a:lstStyle/>
+          <a:p>
+            <a:pPr algn="ctr" indent="0" marL="0">
+              <a:buNone/>
+            </a:pPr>
+            <a:r>
+              <a:rPr lang="en-US" sz="1350" b="1" dirty="0">
+                <a:solidFill>
+                  <a:srgbClr val="FFFFFF"/>
+                </a:solidFill>
+                <a:latin typeface="Georgia" pitchFamily="34" charset="0"/>
+                <a:ea typeface="Georgia" pitchFamily="34" charset="-122"/>
+                <a:cs typeface="Georgia" pitchFamily="34" charset="-120"/>
+              </a:rPr>
+              <a:t>Authentification</a:t>
+            </a:r>
+            <a:endParaRPr lang="en-US" sz="1350" dirty="0"/>
+          </a:p>
+        </p:txBody>
+      </p:sp>
+      <p:sp>
+        <p:nvSpPr>
+          <p:cNvPr id="12" name="Text 10"/>
+          <p:cNvSpPr/>
+          <p:nvPr/>
+        </p:nvSpPr>
+        <p:spPr>
+          <a:xfrm>
+            <a:off x="713232" y="4663440"/>
+            <a:ext cx="2176272" cy="457200"/>
+          </a:xfrm>
+          <a:prstGeom prst="rect">
+            <a:avLst/>
+          </a:prstGeom>
+          <a:noFill/>
+          <a:ln/>
+        </p:spPr>
+        <p:txBody>
+          <a:bodyPr wrap="square" lIns="0" tIns="0" rIns="0" bIns="0" rtlCol="0" anchor="t"/>
+          <a:lstStyle/>
+          <a:p>
+            <a:pPr algn="ctr" indent="0" marL="0">
+              <a:lnSpc>
+                <a:spcPts val="1400"/>
+              </a:lnSpc>
+              <a:buNone/>
+            </a:pPr>
+            <a:r>
+              <a:rPr lang="en-US" sz="1050" dirty="0">
+                <a:solidFill>
+                  <a:srgbClr val="CBD8EE"/>
+                </a:solidFill>
+                <a:latin typeface="Calibri" pitchFamily="34" charset="0"/>
+                <a:ea typeface="Calibri" pitchFamily="34" charset="-122"/>
+                <a:cs typeface="Calibri" pitchFamily="34" charset="-120"/>
+              </a:rPr>
+              <a:t>Connexion et contrôle des rôles</a:t>
+            </a:r>
+            <a:endParaRPr lang="en-US" sz="1050" dirty="0"/>
+          </a:p>
+        </p:txBody>
+      </p:sp>
+      <p:sp>
+        <p:nvSpPr>
+          <p:cNvPr id="13" name="Shape 11"/>
+          <p:cNvSpPr/>
+          <p:nvPr/>
+        </p:nvSpPr>
+        <p:spPr>
+          <a:xfrm>
+            <a:off x="3383280" y="3611880"/>
+            <a:ext cx="2468880" cy="1600200"/>
+          </a:xfrm>
+          <a:prstGeom prst="roundRect">
+            <a:avLst>
+              <a:gd name="adj" fmla="val 4571"/>
+            </a:avLst>
+          </a:prstGeom>
+          <a:solidFill>
+            <a:srgbClr val="1D4EA0"/>
+          </a:solidFill>
+          <a:ln w="12700">
+            <a:solidFill>
+              <a:srgbClr val="1D4EA0"/>
+            </a:solidFill>
+            <a:prstDash val="solid"/>
+          </a:ln>
+        </p:spPr>
+      </p:sp>
+      <p:sp>
+        <p:nvSpPr>
+          <p:cNvPr id="14" name="Shape 12"/>
+          <p:cNvSpPr/>
+          <p:nvPr/>
+        </p:nvSpPr>
+        <p:spPr>
+          <a:xfrm>
+            <a:off x="4416552" y="3803904"/>
+            <a:ext cx="402336" cy="402336"/>
+          </a:xfrm>
+          <a:prstGeom prst="ellipse">
+            <a:avLst/>
+          </a:prstGeom>
+          <a:solidFill>
+            <a:srgbClr val="0A2558"/>
+          </a:solidFill>
+          <a:ln w="12700">
+            <a:solidFill>
+              <a:srgbClr val="0A2558"/>
+            </a:solidFill>
+            <a:prstDash val="solid"/>
+          </a:ln>
+        </p:spPr>
+      </p:sp>
+      <p:sp>
+        <p:nvSpPr>
+          <p:cNvPr id="15" name="Text 13"/>
+          <p:cNvSpPr/>
+          <p:nvPr/>
+        </p:nvSpPr>
+        <p:spPr>
+          <a:xfrm>
+            <a:off x="4416552" y="3803904"/>
+            <a:ext cx="402336" cy="402336"/>
+          </a:xfrm>
+          <a:prstGeom prst="rect">
+            <a:avLst/>
+          </a:prstGeom>
+          <a:noFill/>
+          <a:ln/>
+        </p:spPr>
+        <p:txBody>
+          <a:bodyPr wrap="square" lIns="0" tIns="0" rIns="0" bIns="0" rtlCol="0" anchor="ctr"/>
+          <a:lstStyle/>
+          <a:p>
+            <a:pPr algn="ctr" indent="0" marL="0">
+              <a:buNone/>
+            </a:pPr>
+            <a:r>
+              <a:rPr lang="en-US" sz="1300" b="1" dirty="0">
+                <a:solidFill>
+                  <a:srgbClr val="FFFFFF"/>
+                </a:solidFill>
+                <a:latin typeface="Georgia" pitchFamily="34" charset="0"/>
+                <a:ea typeface="Georgia" pitchFamily="34" charset="-122"/>
+                <a:cs typeface="Georgia" pitchFamily="34" charset="-120"/>
+              </a:rPr>
+              <a:t>2</a:t>
+            </a:r>
+            <a:endParaRPr lang="en-US" sz="1300" dirty="0"/>
+          </a:p>
+        </p:txBody>
+      </p:sp>
+      <p:sp>
+        <p:nvSpPr>
+          <p:cNvPr id="16" name="Text 14"/>
+          <p:cNvSpPr/>
+          <p:nvPr/>
+        </p:nvSpPr>
+        <p:spPr>
+          <a:xfrm>
+            <a:off x="3529584" y="4297680"/>
+            <a:ext cx="2176272" cy="365760"/>
+          </a:xfrm>
+          <a:prstGeom prst="rect">
+            <a:avLst/>
+          </a:prstGeom>
+          <a:noFill/>
+          <a:ln/>
+        </p:spPr>
+        <p:txBody>
+          <a:bodyPr wrap="square" lIns="0" tIns="0" rIns="0" bIns="0" rtlCol="0" anchor="ctr"/>
+          <a:lstStyle/>
+          <a:p>
+            <a:pPr algn="ctr" indent="0" marL="0">
+              <a:buNone/>
+            </a:pPr>
+            <a:r>
+              <a:rPr lang="en-US" sz="1350" b="1" dirty="0">
+                <a:solidFill>
+                  <a:srgbClr val="FFFFFF"/>
+                </a:solidFill>
+                <a:latin typeface="Georgia" pitchFamily="34" charset="0"/>
+                <a:ea typeface="Georgia" pitchFamily="34" charset="-122"/>
+                <a:cs typeface="Georgia" pitchFamily="34" charset="-120"/>
+              </a:rPr>
+              <a:t>Gestion du réseau</a:t>
+            </a:r>
+            <a:endParaRPr lang="en-US" sz="1350" dirty="0"/>
+          </a:p>
+        </p:txBody>
+      </p:sp>
+      <p:sp>
+        <p:nvSpPr>
+          <p:cNvPr id="17" name="Text 15"/>
+          <p:cNvSpPr/>
+          <p:nvPr/>
+        </p:nvSpPr>
+        <p:spPr>
+          <a:xfrm>
+            <a:off x="3529584" y="4663440"/>
+            <a:ext cx="2176272" cy="457200"/>
+          </a:xfrm>
+          <a:prstGeom prst="rect">
+            <a:avLst/>
+          </a:prstGeom>
+          <a:noFill/>
+          <a:ln/>
+        </p:spPr>
+        <p:txBody>
+          <a:bodyPr wrap="square" lIns="0" tIns="0" rIns="0" bIns="0" rtlCol="0" anchor="t"/>
+          <a:lstStyle/>
+          <a:p>
+            <a:pPr algn="ctr" indent="0" marL="0">
+              <a:lnSpc>
+                <a:spcPts val="1400"/>
+              </a:lnSpc>
+              <a:buNone/>
+            </a:pPr>
+            <a:r>
+              <a:rPr lang="en-US" sz="1050" dirty="0">
+                <a:solidFill>
+                  <a:srgbClr val="CBD8EE"/>
+                </a:solidFill>
+                <a:latin typeface="Calibri" pitchFamily="34" charset="0"/>
+                <a:ea typeface="Calibri" pitchFamily="34" charset="-122"/>
+                <a:cs typeface="Calibri" pitchFamily="34" charset="-120"/>
+              </a:rPr>
+              <a:t>Agences, employés, clients et objectifs</a:t>
+            </a:r>
+            <a:endParaRPr lang="en-US" sz="1050" dirty="0"/>
+          </a:p>
+        </p:txBody>
+      </p:sp>
+      <p:sp>
+        <p:nvSpPr>
+          <p:cNvPr id="18" name="Shape 16"/>
+          <p:cNvSpPr/>
+          <p:nvPr/>
+        </p:nvSpPr>
+        <p:spPr>
+          <a:xfrm>
+            <a:off x="6199632" y="3611880"/>
+            <a:ext cx="2468880" cy="1600200"/>
+          </a:xfrm>
+          <a:prstGeom prst="roundRect">
+            <a:avLst>
+              <a:gd name="adj" fmla="val 4571"/>
+            </a:avLst>
+          </a:prstGeom>
+          <a:solidFill>
+            <a:srgbClr val="1D4EA0"/>
+          </a:solidFill>
+          <a:ln w="12700">
+            <a:solidFill>
+              <a:srgbClr val="1D4EA0"/>
+            </a:solidFill>
+            <a:prstDash val="solid"/>
+          </a:ln>
+        </p:spPr>
+      </p:sp>
+      <p:sp>
+        <p:nvSpPr>
+          <p:cNvPr id="19" name="Shape 17"/>
+          <p:cNvSpPr/>
+          <p:nvPr/>
+        </p:nvSpPr>
+        <p:spPr>
+          <a:xfrm>
+            <a:off x="7232904" y="3803904"/>
+            <a:ext cx="402336" cy="402336"/>
+          </a:xfrm>
+          <a:prstGeom prst="ellipse">
+            <a:avLst/>
+          </a:prstGeom>
+          <a:solidFill>
+            <a:srgbClr val="0A2558"/>
+          </a:solidFill>
+          <a:ln w="12700">
+            <a:solidFill>
+              <a:srgbClr val="0A2558"/>
+            </a:solidFill>
+            <a:prstDash val="solid"/>
+          </a:ln>
+        </p:spPr>
+      </p:sp>
+      <p:sp>
+        <p:nvSpPr>
+          <p:cNvPr id="20" name="Text 18"/>
+          <p:cNvSpPr/>
+          <p:nvPr/>
+        </p:nvSpPr>
+        <p:spPr>
+          <a:xfrm>
+            <a:off x="7232904" y="3803904"/>
+            <a:ext cx="402336" cy="402336"/>
+          </a:xfrm>
+          <a:prstGeom prst="rect">
+            <a:avLst/>
+          </a:prstGeom>
+          <a:noFill/>
+          <a:ln/>
+        </p:spPr>
+        <p:txBody>
+          <a:bodyPr wrap="square" lIns="0" tIns="0" rIns="0" bIns="0" rtlCol="0" anchor="ctr"/>
+          <a:lstStyle/>
+          <a:p>
+            <a:pPr algn="ctr" indent="0" marL="0">
+              <a:buNone/>
+            </a:pPr>
+            <a:r>
+              <a:rPr lang="en-US" sz="1300" b="1" dirty="0">
+                <a:solidFill>
+                  <a:srgbClr val="FFFFFF"/>
+                </a:solidFill>
+                <a:latin typeface="Georgia" pitchFamily="34" charset="0"/>
+                <a:ea typeface="Georgia" pitchFamily="34" charset="-122"/>
+                <a:cs typeface="Georgia" pitchFamily="34" charset="-120"/>
+              </a:rPr>
+              <a:t>3</a:t>
+            </a:r>
+            <a:endParaRPr lang="en-US" sz="1300" dirty="0"/>
+          </a:p>
+        </p:txBody>
+      </p:sp>
+      <p:sp>
+        <p:nvSpPr>
+          <p:cNvPr id="21" name="Text 19"/>
+          <p:cNvSpPr/>
+          <p:nvPr/>
+        </p:nvSpPr>
+        <p:spPr>
+          <a:xfrm>
+            <a:off x="6345936" y="4297680"/>
+            <a:ext cx="2176272" cy="365760"/>
+          </a:xfrm>
+          <a:prstGeom prst="rect">
+            <a:avLst/>
+          </a:prstGeom>
+          <a:noFill/>
+          <a:ln/>
+        </p:spPr>
+        <p:txBody>
+          <a:bodyPr wrap="square" lIns="0" tIns="0" rIns="0" bIns="0" rtlCol="0" anchor="ctr"/>
+          <a:lstStyle/>
+          <a:p>
+            <a:pPr algn="ctr" indent="0" marL="0">
+              <a:buNone/>
+            </a:pPr>
+            <a:r>
+              <a:rPr lang="en-US" sz="1350" b="1" dirty="0">
+                <a:solidFill>
+                  <a:srgbClr val="FFFFFF"/>
+                </a:solidFill>
+                <a:latin typeface="Georgia" pitchFamily="34" charset="0"/>
+                <a:ea typeface="Georgia" pitchFamily="34" charset="-122"/>
+                <a:cs typeface="Georgia" pitchFamily="34" charset="-120"/>
+              </a:rPr>
+              <a:t>Pointage</a:t>
+            </a:r>
+            <a:endParaRPr lang="en-US" sz="1350" dirty="0"/>
+          </a:p>
+        </p:txBody>
+      </p:sp>
+      <p:sp>
+        <p:nvSpPr>
+          <p:cNvPr id="22" name="Text 20"/>
+          <p:cNvSpPr/>
+          <p:nvPr/>
+        </p:nvSpPr>
+        <p:spPr>
+          <a:xfrm>
+            <a:off x="6345936" y="4663440"/>
+            <a:ext cx="2176272" cy="457200"/>
+          </a:xfrm>
+          <a:prstGeom prst="rect">
+            <a:avLst/>
+          </a:prstGeom>
+          <a:noFill/>
+          <a:ln/>
+        </p:spPr>
+        <p:txBody>
+          <a:bodyPr wrap="square" lIns="0" tIns="0" rIns="0" bIns="0" rtlCol="0" anchor="t"/>
+          <a:lstStyle/>
+          <a:p>
+            <a:pPr algn="ctr" indent="0" marL="0">
+              <a:lnSpc>
+                <a:spcPts val="1400"/>
+              </a:lnSpc>
+              <a:buNone/>
+            </a:pPr>
+            <a:r>
+              <a:rPr lang="en-US" sz="1050" dirty="0">
+                <a:solidFill>
+                  <a:srgbClr val="CBD8EE"/>
+                </a:solidFill>
+                <a:latin typeface="Calibri" pitchFamily="34" charset="0"/>
+                <a:ea typeface="Calibri" pitchFamily="34" charset="-122"/>
+                <a:cs typeface="Calibri" pitchFamily="34" charset="-120"/>
+              </a:rPr>
+              <a:t>Arrivée, départ et statut de présence</a:t>
+            </a:r>
+            <a:endParaRPr lang="en-US" sz="1050" dirty="0"/>
+          </a:p>
+        </p:txBody>
+      </p:sp>
+      <p:sp>
+        <p:nvSpPr>
+          <p:cNvPr id="23" name="Shape 21"/>
+          <p:cNvSpPr/>
+          <p:nvPr/>
+        </p:nvSpPr>
+        <p:spPr>
+          <a:xfrm>
+            <a:off x="9015984" y="3611880"/>
+            <a:ext cx="2468880" cy="1600200"/>
+          </a:xfrm>
+          <a:prstGeom prst="roundRect">
+            <a:avLst>
+              <a:gd name="adj" fmla="val 4571"/>
+            </a:avLst>
+          </a:prstGeom>
+          <a:solidFill>
+            <a:srgbClr val="1D4EA0"/>
+          </a:solidFill>
+          <a:ln w="12700">
+            <a:solidFill>
+              <a:srgbClr val="1D4EA0"/>
+            </a:solidFill>
+            <a:prstDash val="solid"/>
+          </a:ln>
+        </p:spPr>
+      </p:sp>
+      <p:sp>
+        <p:nvSpPr>
+          <p:cNvPr id="24" name="Shape 22"/>
+          <p:cNvSpPr/>
+          <p:nvPr/>
+        </p:nvSpPr>
+        <p:spPr>
+          <a:xfrm>
+            <a:off x="10049256" y="3803904"/>
+            <a:ext cx="402336" cy="402336"/>
+          </a:xfrm>
+          <a:prstGeom prst="ellipse">
+            <a:avLst/>
+          </a:prstGeom>
+          <a:solidFill>
+            <a:srgbClr val="0A2558"/>
+          </a:solidFill>
+          <a:ln w="12700">
+            <a:solidFill>
+              <a:srgbClr val="0A2558"/>
+            </a:solidFill>
+            <a:prstDash val="solid"/>
+          </a:ln>
+        </p:spPr>
+      </p:sp>
+      <p:sp>
+        <p:nvSpPr>
+          <p:cNvPr id="25" name="Text 23"/>
+          <p:cNvSpPr/>
+          <p:nvPr/>
+        </p:nvSpPr>
+        <p:spPr>
+          <a:xfrm>
+            <a:off x="10049256" y="3803904"/>
+            <a:ext cx="402336" cy="402336"/>
+          </a:xfrm>
+          <a:prstGeom prst="rect">
+            <a:avLst/>
+          </a:prstGeom>
+          <a:noFill/>
+          <a:ln/>
+        </p:spPr>
+        <p:txBody>
+          <a:bodyPr wrap="square" lIns="0" tIns="0" rIns="0" bIns="0" rtlCol="0" anchor="ctr"/>
+          <a:lstStyle/>
+          <a:p>
+            <a:pPr algn="ctr" indent="0" marL="0">
+              <a:buNone/>
+            </a:pPr>
+            <a:r>
+              <a:rPr lang="en-US" sz="1300" b="1" dirty="0">
+                <a:solidFill>
+                  <a:srgbClr val="FFFFFF"/>
+                </a:solidFill>
+                <a:latin typeface="Georgia" pitchFamily="34" charset="0"/>
+                <a:ea typeface="Georgia" pitchFamily="34" charset="-122"/>
+                <a:cs typeface="Georgia" pitchFamily="34" charset="-120"/>
+              </a:rPr>
+              <a:t>4</a:t>
+            </a:r>
+            <a:endParaRPr lang="en-US" sz="1300" dirty="0"/>
+          </a:p>
+        </p:txBody>
+      </p:sp>
+      <p:sp>
+        <p:nvSpPr>
+          <p:cNvPr id="26" name="Text 24"/>
+          <p:cNvSpPr/>
+          <p:nvPr/>
+        </p:nvSpPr>
+        <p:spPr>
+          <a:xfrm>
+            <a:off x="9162288" y="4297680"/>
+            <a:ext cx="2176272" cy="365760"/>
+          </a:xfrm>
+          <a:prstGeom prst="rect">
+            <a:avLst/>
+          </a:prstGeom>
+          <a:noFill/>
+          <a:ln/>
+        </p:spPr>
+        <p:txBody>
+          <a:bodyPr wrap="square" lIns="0" tIns="0" rIns="0" bIns="0" rtlCol="0" anchor="ctr"/>
+          <a:lstStyle/>
+          <a:p>
+            <a:pPr algn="ctr" indent="0" marL="0">
+              <a:buNone/>
+            </a:pPr>
+            <a:r>
+              <a:rPr lang="en-US" sz="1350" b="1" dirty="0">
+                <a:solidFill>
+                  <a:srgbClr val="FFFFFF"/>
+                </a:solidFill>
+                <a:latin typeface="Georgia" pitchFamily="34" charset="0"/>
+                <a:ea typeface="Georgia" pitchFamily="34" charset="-122"/>
+                <a:cs typeface="Georgia" pitchFamily="34" charset="-120"/>
+              </a:rPr>
+              <a:t>Tableau de bord</a:t>
+            </a:r>
+            <a:endParaRPr lang="en-US" sz="1350" dirty="0"/>
+          </a:p>
+        </p:txBody>
+      </p:sp>
+      <p:sp>
+        <p:nvSpPr>
+          <p:cNvPr id="27" name="Text 25"/>
+          <p:cNvSpPr/>
+          <p:nvPr/>
+        </p:nvSpPr>
+        <p:spPr>
+          <a:xfrm>
+            <a:off x="9162288" y="4663440"/>
+            <a:ext cx="2176272" cy="457200"/>
+          </a:xfrm>
+          <a:prstGeom prst="rect">
+            <a:avLst/>
+          </a:prstGeom>
+          <a:noFill/>
+          <a:ln/>
+        </p:spPr>
+        <p:txBody>
+          <a:bodyPr wrap="square" lIns="0" tIns="0" rIns="0" bIns="0" rtlCol="0" anchor="t"/>
+          <a:lstStyle/>
+          <a:p>
+            <a:pPr algn="ctr" indent="0" marL="0">
+              <a:lnSpc>
+                <a:spcPts val="1400"/>
+              </a:lnSpc>
+              <a:buNone/>
+            </a:pPr>
+            <a:r>
+              <a:rPr lang="en-US" sz="1050" dirty="0">
+                <a:solidFill>
+                  <a:srgbClr val="CBD8EE"/>
+                </a:solidFill>
+                <a:latin typeface="Calibri" pitchFamily="34" charset="0"/>
+                <a:ea typeface="Calibri" pitchFamily="34" charset="-122"/>
+                <a:cs typeface="Calibri" pitchFamily="34" charset="-120"/>
+              </a:rPr>
+              <a:t>Indicateurs de synthèse de l'application</a:t>
+            </a:r>
+            <a:endParaRPr lang="en-US" sz="1050" dirty="0"/>
+          </a:p>
+        </p:txBody>
+      </p:sp>
+      <p:sp>
+        <p:nvSpPr>
+          <p:cNvPr id="28" name="Text 26"/>
+          <p:cNvSpPr/>
+          <p:nvPr/>
+        </p:nvSpPr>
+        <p:spPr>
+          <a:xfrm>
+            <a:off x="566928" y="5440680"/>
+            <a:ext cx="10058400" cy="365760"/>
+          </a:xfrm>
+          <a:prstGeom prst="rect">
+            <a:avLst/>
+          </a:prstGeom>
+          <a:noFill/>
+          <a:ln/>
+        </p:spPr>
+        <p:txBody>
+          <a:bodyPr wrap="square" lIns="0" tIns="0" rIns="0" bIns="0" rtlCol="0" anchor="ctr"/>
+          <a:lstStyle/>
+          <a:p>
+            <a:pPr indent="0" marL="0">
+              <a:buNone/>
+            </a:pPr>
+            <a:r>
+              <a:rPr lang="en-US" sz="1200" i="1" dirty="0">
+                <a:solidFill>
+                  <a:srgbClr val="9FB6DC"/>
+                </a:solidFill>
+                <a:latin typeface="Calibri" pitchFamily="34" charset="0"/>
+                <a:ea typeface="Calibri" pitchFamily="34" charset="-122"/>
+                <a:cs typeface="Calibri" pitchFamily="34" charset="-120"/>
+              </a:rPr>
+              <a:t>Les rapports Power BI ont été présentés en images dans la partie précédente.</a:t>
+            </a:r>
+            <a:endParaRPr lang="en-US" sz="1200" dirty="0"/>
+          </a:p>
+        </p:txBody>
       </p:sp>
     </p:spTree>
   </p:cSld>

</xml_diff>

<commit_message>
Format des noms d'encadrants : NOM en majuscules avant le prénom
- Page de garde, page de signatures, remerciements : M. ELMOULA Melek Aziz
  et M. ABIDI Heni
- Même format dans la présentation de soutenance et le brief projet
</commit_message>
<xml_diff>
--- a/presentation/Soutenance_PFE_Oussema_Korbosli.pptx
+++ b/presentation/Soutenance_PFE_Oussema_Korbosli.pptx
@@ -4482,7 +4482,7 @@
                 <a:ea typeface="Calibri" pitchFamily="34" charset="-122"/>
                 <a:cs typeface="Calibri" pitchFamily="34" charset="-120"/>
               </a:rPr>
-              <a:t>M. Melek Aziz Elmoula</a:t>
+              <a:t>M. ELMOULA Melek Aziz</a:t>
             </a:r>
             <a:endParaRPr lang="en-US" sz="1250" dirty="0"/>
           </a:p>
@@ -4535,7 +4535,7 @@
                 <a:ea typeface="Calibri" pitchFamily="34" charset="-122"/>
                 <a:cs typeface="Calibri" pitchFamily="34" charset="-120"/>
               </a:rPr>
-              <a:t>M. Heni Abidi</a:t>
+              <a:t>M. ABIDI Heni</a:t>
             </a:r>
             <a:endParaRPr lang="en-US" sz="1250" dirty="0"/>
           </a:p>
@@ -27430,7 +27430,7 @@
                 <a:ea typeface="Georgia" pitchFamily="34" charset="-122"/>
                 <a:cs typeface="Georgia" pitchFamily="34" charset="-120"/>
               </a:rPr>
-              <a:t>M. Melek Aziz Elmoula</a:t>
+              <a:t>M. ELMOULA Melek Aziz</a:t>
             </a:r>
             <a:endParaRPr lang="en-US" sz="1450" dirty="0"/>
           </a:p>

</xml_diff>

<commit_message>
Presentation synchronisee avec le rapport corrige
- Nouveau diagramme de cas d'utilisation reinsere (image regeneree)
- Slide << Identification des acteurs >> : descriptions alignees sur le
  tableau 2.1 corrige (13 cas pour l'admin, consultation des employes pour
  le directeur, notifications pour l'utilisateur)
- Encadre << Lecture du diagramme >> : 13 cas, 5 cas, 3 cas
- Besoins fonctionnels : double validation des demandes
- Modele en etoile : deux grains, datamart ETL (fait_agence / dim_agence,
  fait_objectif / dim_gestionnaire) et couche semantique V_BI_*
- Chaine ETL : integration sur SK_AGENCE puis SK_UTILISATEUR, source
  CLIENT_BTK, 49 entites consolidees

Rapport : << 49 agences >> -> << 49 entites >> (figure 4.4 et section 4.3.2)
pour ne pas confondre les 45 agences du reseau et les 49 entites remontees
par la requete d'extraction.
</commit_message>
<xml_diff>
--- a/presentation/Soutenance_PFE_Oussema_Korbosli.pptx
+++ b/presentation/Soutenance_PFE_Oussema_Korbosli.pptx
@@ -5976,7 +5976,7 @@
                 <a:ea typeface="Calibri" pitchFamily="34" charset="-122"/>
                 <a:cs typeface="Calibri" pitchFamily="34" charset="-120"/>
               </a:rPr>
-              <a:t>Gère les agences, les employés et les clients · valide les demandes · consulte le journal d'audit · supervise le volet décisionnel</a:t>
+              <a:t>Couvre les 13 cas d'utilisation : rôles et droits · agences, employés, clients · demandes · pointage · journal d'audit · volet décisionnel</a:t>
             </a:r>
             <a:endParaRPr lang="en-US" sz="1200" dirty="0"/>
           </a:p>
@@ -6207,7 +6207,7 @@
                 <a:ea typeface="Calibri" pitchFamily="34" charset="-122"/>
                 <a:cs typeface="Calibri" pitchFamily="34" charset="-120"/>
               </a:rPr>
-              <a:t>Soumet les demandes de création · valide les modifications des employés · consulte les objectifs et les indicateurs</a:t>
+              <a:t>Consulte les employés, les objectifs et le tableau de bord · soumet les demandes de création · valide les modifications des employés</a:t>
             </a:r>
             <a:endParaRPr lang="en-US" sz="1200" dirty="0"/>
           </a:p>
@@ -6438,7 +6438,7 @@
                 <a:ea typeface="Calibri" pitchFamily="34" charset="-122"/>
                 <a:cs typeface="Calibri" pitchFamily="34" charset="-120"/>
               </a:rPr>
-              <a:t>Consulte les données autorisées · effectue son pointage · soumet les demandes le concernant</a:t>
+              <a:t>Pointe son arrivée et son départ · soumet les demandes de modification de ses propres informations · reçoit ses notifications</a:t>
             </a:r>
             <a:endParaRPr lang="en-US" sz="1200" dirty="0"/>
           </a:p>
@@ -7496,7 +7496,7 @@
                 <a:ea typeface="Calibri" pitchFamily="34" charset="-122"/>
                 <a:cs typeface="Calibri" pitchFamily="34" charset="-120"/>
               </a:rPr>
-              <a:t>Demandes soumises, validées ou refusées, journalisées</a:t>
+              <a:t>Double validation : approbation du directeur puis exécution par l'admin</a:t>
             </a:r>
             <a:endParaRPr lang="en-US" sz="1200" dirty="0"/>
           </a:p>
@@ -10663,8 +10663,8 @@
         </p:blipFill>
         <p:spPr>
           <a:xfrm>
-            <a:off x="776740" y="1298448"/>
-            <a:ext cx="7444217" cy="4846320"/>
+            <a:off x="1514819" y="1298448"/>
+            <a:ext cx="5968058" cy="4846320"/>
           </a:xfrm>
           <a:prstGeom prst="rect">
             <a:avLst/>
@@ -10768,7 +10768,7 @@
                 <a:ea typeface="Calibri" pitchFamily="34" charset="-122"/>
                 <a:cs typeface="Calibri" pitchFamily="34" charset="-120"/>
               </a:rPr>
-              <a:t>Trois acteurs distincts</a:t>
+              <a:t>Trois acteurs, treize cas d'utilisation</a:t>
             </a:r>
             <a:endParaRPr lang="en-US" sz="1150" dirty="0"/>
           </a:p>
@@ -10832,7 +10832,7 @@
                 <a:ea typeface="Calibri" pitchFamily="34" charset="-122"/>
                 <a:cs typeface="Calibri" pitchFamily="34" charset="-120"/>
               </a:rPr>
-              <a:t>« S'authentifier » commun à tous (include)</a:t>
+              <a:t>Chaque cas inclut « S'authentifier » (include)</a:t>
             </a:r>
             <a:endParaRPr lang="en-US" sz="1150" dirty="0"/>
           </a:p>
@@ -10896,7 +10896,7 @@
                 <a:ea typeface="Calibri" pitchFamily="34" charset="-122"/>
                 <a:cs typeface="Calibri" pitchFamily="34" charset="-120"/>
               </a:rPr>
-              <a:t>L'administrateur concentre la gestion</a:t>
+              <a:t>Administrateur : les 13 cas, sans exception</a:t>
             </a:r>
             <a:endParaRPr lang="en-US" sz="1150" dirty="0"/>
           </a:p>
@@ -10960,7 +10960,7 @@
                 <a:ea typeface="Calibri" pitchFamily="34" charset="-122"/>
                 <a:cs typeface="Calibri" pitchFamily="34" charset="-120"/>
               </a:rPr>
-              <a:t>Le directeur soumet et consulte</a:t>
+              <a:t>Directeur commercial : 5 cas, dont les employés en consultation</a:t>
             </a:r>
             <a:endParaRPr lang="en-US" sz="1150" dirty="0"/>
           </a:p>
@@ -11024,7 +11024,7 @@
                 <a:ea typeface="Calibri" pitchFamily="34" charset="-122"/>
                 <a:cs typeface="Calibri" pitchFamily="34" charset="-120"/>
               </a:rPr>
-              <a:t>L'utilisateur pointe et consulte</a:t>
+              <a:t>Utilisateur : 3 cas — pointage, demandes, notifications</a:t>
             </a:r>
             <a:endParaRPr lang="en-US" sz="1150" dirty="0"/>
           </a:p>
@@ -11609,7 +11609,7 @@
                 <a:ea typeface="Calibri" pitchFamily="34" charset="-122"/>
                 <a:cs typeface="Calibri" pitchFamily="34" charset="-120"/>
               </a:rPr>
-              <a:t>Un grain unique — l'agence — et peu de dimensions : le modèle en étoile offre la lisibilité attendue par un outil libre-service comme Power BI.</a:t>
+              <a:t>Des grains homogènes — l'agence, puis le couple agence × gestionnaire — et peu de dimensions : l'étoile offre la lisibilité attendue par un outil libre-service comme Power BI.</a:t>
             </a:r>
             <a:endParaRPr lang="en-US" sz="1250" dirty="0"/>
           </a:p>
@@ -11650,8 +11650,8 @@
         </p:nvSpPr>
         <p:spPr>
           <a:xfrm>
-            <a:off x="6812280" y="1993392"/>
-            <a:ext cx="4663440" cy="365760"/>
+            <a:off x="6812280" y="1975104"/>
+            <a:ext cx="4663440" cy="256032"/>
           </a:xfrm>
           <a:prstGeom prst="rect">
             <a:avLst/>
@@ -11667,96 +11667,15 @@
               <a:buNone/>
             </a:pPr>
             <a:r>
-              <a:rPr lang="en-US" sz="1400" b="1" dirty="0">
-                <a:solidFill>
-                  <a:srgbClr val="0A2558"/>
-                </a:solidFill>
-                <a:latin typeface="Consolas" pitchFamily="34" charset="0"/>
-                <a:ea typeface="Consolas" pitchFamily="34" charset="-122"/>
-                <a:cs typeface="Consolas" pitchFamily="34" charset="-120"/>
-              </a:rPr>
-              <a:t>fait_agence</a:t>
-            </a:r>
-            <a:endParaRPr lang="en-US" sz="1400" dirty="0"/>
-          </a:p>
-        </p:txBody>
-      </p:sp>
-      <p:sp>
-        <p:nvSpPr>
-          <p:cNvPr id="20" name="Text 18"/>
-          <p:cNvSpPr/>
-          <p:nvPr/>
-        </p:nvSpPr>
-        <p:spPr>
-          <a:xfrm>
-            <a:off x="6812280" y="2377440"/>
-            <a:ext cx="4663440" cy="731520"/>
-          </a:xfrm>
-          <a:prstGeom prst="rect">
-            <a:avLst/>
-          </a:prstGeom>
-          <a:noFill/>
-          <a:ln/>
-        </p:spPr>
-        <p:txBody>
-          <a:bodyPr wrap="square" lIns="0" tIns="0" rIns="0" bIns="0" rtlCol="0" anchor="t"/>
-          <a:lstStyle/>
-          <a:p>
-            <a:pPr indent="0" marL="0">
-              <a:lnSpc>
-                <a:spcPts val="1700"/>
-              </a:lnSpc>
-              <a:buNone/>
-            </a:pPr>
-            <a:r>
-              <a:rPr lang="en-US" sz="1200" dirty="0">
-                <a:solidFill>
-                  <a:srgbClr val="1B2A44"/>
+              <a:rPr lang="en-US" sz="1000" b="1" spc="200" kern="0" dirty="0">
+                <a:solidFill>
+                  <a:srgbClr val="3C6FC3"/>
                 </a:solidFill>
                 <a:latin typeface="Calibri" pitchFamily="34" charset="0"/>
                 <a:ea typeface="Calibri" pitchFamily="34" charset="-122"/>
                 <a:cs typeface="Calibri" pitchFamily="34" charset="-120"/>
               </a:rPr>
-              <a:t>Effectif · gestionnaires · clients · comptes ouverts · production de crédits · collecte d'épargne · taux de présence</a:t>
-            </a:r>
-            <a:endParaRPr lang="en-US" sz="1200" dirty="0"/>
-          </a:p>
-        </p:txBody>
-      </p:sp>
-      <p:sp>
-        <p:nvSpPr>
-          <p:cNvPr id="21" name="Text 19"/>
-          <p:cNvSpPr/>
-          <p:nvPr/>
-        </p:nvSpPr>
-        <p:spPr>
-          <a:xfrm>
-            <a:off x="6812280" y="3200400"/>
-            <a:ext cx="4663440" cy="256032"/>
-          </a:xfrm>
-          <a:prstGeom prst="rect">
-            <a:avLst/>
-          </a:prstGeom>
-          <a:noFill/>
-          <a:ln/>
-        </p:spPr>
-        <p:txBody>
-          <a:bodyPr wrap="square" lIns="0" tIns="0" rIns="0" bIns="0" rtlCol="0" anchor="ctr"/>
-          <a:lstStyle/>
-          <a:p>
-            <a:pPr indent="0" marL="0">
-              <a:buNone/>
-            </a:pPr>
-            <a:r>
-              <a:rPr lang="en-US" sz="1000" b="1" spc="200" kern="0" dirty="0">
-                <a:solidFill>
-                  <a:srgbClr val="3C6FC3"/>
-                </a:solidFill>
-                <a:latin typeface="Calibri" pitchFamily="34" charset="0"/>
-                <a:ea typeface="Calibri" pitchFamily="34" charset="-122"/>
-                <a:cs typeface="Calibri" pitchFamily="34" charset="-120"/>
-              </a:rPr>
-              <a:t>TABLES DE DIMENSIONS</a:t>
+              <a:t>DATAMART CHARGÉ PAR L'ETL</a:t>
             </a:r>
             <a:endParaRPr lang="en-US" sz="1000" dirty="0"/>
           </a:p>
@@ -11764,13 +11683,13 @@
       </p:sp>
       <p:sp>
         <p:nvSpPr>
-          <p:cNvPr id="22" name="Shape 20"/>
-          <p:cNvSpPr/>
-          <p:nvPr/>
-        </p:nvSpPr>
-        <p:spPr>
-          <a:xfrm>
-            <a:off x="6812280" y="3621024"/>
+          <p:cNvPr id="20" name="Shape 18"/>
+          <p:cNvSpPr/>
+          <p:nvPr/>
+        </p:nvSpPr>
+        <p:spPr>
+          <a:xfrm>
+            <a:off x="6812280" y="2395728"/>
             <a:ext cx="109728" cy="109728"/>
           </a:xfrm>
           <a:prstGeom prst="ellipse">
@@ -11789,13 +11708,13 @@
       </p:sp>
       <p:sp>
         <p:nvSpPr>
-          <p:cNvPr id="23" name="Text 21"/>
-          <p:cNvSpPr/>
-          <p:nvPr/>
-        </p:nvSpPr>
-        <p:spPr>
-          <a:xfrm>
-            <a:off x="7086600" y="3474720"/>
+          <p:cNvPr id="21" name="Text 19"/>
+          <p:cNvSpPr/>
+          <p:nvPr/>
+        </p:nvSpPr>
+        <p:spPr>
+          <a:xfrm>
+            <a:off x="7086600" y="2249424"/>
             <a:ext cx="4389120" cy="420624"/>
           </a:xfrm>
           <a:prstGeom prst="rect">
@@ -11820,7 +11739,7 @@
                 <a:ea typeface="Calibri" pitchFamily="34" charset="-122"/>
                 <a:cs typeface="Calibri" pitchFamily="34" charset="-120"/>
               </a:rPr>
-              <a:t>dim_agence — libellé, district, région</a:t>
+              <a:t>fait_agence / dim_agence — 7 indicateurs au grain de l'agence</a:t>
             </a:r>
             <a:endParaRPr lang="en-US" sz="1150" dirty="0"/>
           </a:p>
@@ -11828,13 +11747,13 @@
       </p:sp>
       <p:sp>
         <p:nvSpPr>
-          <p:cNvPr id="24" name="Shape 22"/>
-          <p:cNvSpPr/>
-          <p:nvPr/>
-        </p:nvSpPr>
-        <p:spPr>
-          <a:xfrm>
-            <a:off x="6812280" y="4078224"/>
+          <p:cNvPr id="22" name="Shape 20"/>
+          <p:cNvSpPr/>
+          <p:nvPr/>
+        </p:nvSpPr>
+        <p:spPr>
+          <a:xfrm>
+            <a:off x="6812280" y="2852928"/>
             <a:ext cx="109728" cy="109728"/>
           </a:xfrm>
           <a:prstGeom prst="ellipse">
@@ -11853,13 +11772,13 @@
       </p:sp>
       <p:sp>
         <p:nvSpPr>
-          <p:cNvPr id="25" name="Text 23"/>
-          <p:cNvSpPr/>
-          <p:nvPr/>
-        </p:nvSpPr>
-        <p:spPr>
-          <a:xfrm>
-            <a:off x="7086600" y="3931920"/>
+          <p:cNvPr id="23" name="Text 21"/>
+          <p:cNvSpPr/>
+          <p:nvPr/>
+        </p:nvSpPr>
+        <p:spPr>
+          <a:xfrm>
+            <a:off x="7086600" y="2706624"/>
             <a:ext cx="4389120" cy="420624"/>
           </a:xfrm>
           <a:prstGeom prst="rect">
@@ -11884,7 +11803,7 @@
                 <a:ea typeface="Calibri" pitchFamily="34" charset="-122"/>
                 <a:cs typeface="Calibri" pitchFamily="34" charset="-120"/>
               </a:rPr>
-              <a:t>période — analyse par mois et exercice</a:t>
+              <a:t>fait_objectif / dim_gestionnaire — production au grain agence × gestionnaire</a:t>
             </a:r>
             <a:endParaRPr lang="en-US" sz="1150" dirty="0"/>
           </a:p>
@@ -11892,13 +11811,52 @@
       </p:sp>
       <p:sp>
         <p:nvSpPr>
-          <p:cNvPr id="26" name="Shape 24"/>
-          <p:cNvSpPr/>
-          <p:nvPr/>
-        </p:nvSpPr>
-        <p:spPr>
-          <a:xfrm>
-            <a:off x="6812280" y="4535424"/>
+          <p:cNvPr id="24" name="Text 22"/>
+          <p:cNvSpPr/>
+          <p:nvPr/>
+        </p:nvSpPr>
+        <p:spPr>
+          <a:xfrm>
+            <a:off x="6812280" y="3712464"/>
+            <a:ext cx="4663440" cy="256032"/>
+          </a:xfrm>
+          <a:prstGeom prst="rect">
+            <a:avLst/>
+          </a:prstGeom>
+          <a:noFill/>
+          <a:ln/>
+        </p:spPr>
+        <p:txBody>
+          <a:bodyPr wrap="square" lIns="0" tIns="0" rIns="0" bIns="0" rtlCol="0" anchor="ctr"/>
+          <a:lstStyle/>
+          <a:p>
+            <a:pPr indent="0" marL="0">
+              <a:buNone/>
+            </a:pPr>
+            <a:r>
+              <a:rPr lang="en-US" sz="1000" b="1" spc="200" kern="0" dirty="0">
+                <a:solidFill>
+                  <a:srgbClr val="3C6FC3"/>
+                </a:solidFill>
+                <a:latin typeface="Calibri" pitchFamily="34" charset="0"/>
+                <a:ea typeface="Calibri" pitchFamily="34" charset="-122"/>
+                <a:cs typeface="Calibri" pitchFamily="34" charset="-120"/>
+              </a:rPr>
+              <a:t>COUCHE SÉMANTIQUE POWER BI</a:t>
+            </a:r>
+            <a:endParaRPr lang="en-US" sz="1000" dirty="0"/>
+          </a:p>
+        </p:txBody>
+      </p:sp>
+      <p:sp>
+        <p:nvSpPr>
+          <p:cNvPr id="25" name="Shape 23"/>
+          <p:cNvSpPr/>
+          <p:nvPr/>
+        </p:nvSpPr>
+        <p:spPr>
+          <a:xfrm>
+            <a:off x="6812280" y="4133088"/>
             <a:ext cx="109728" cy="109728"/>
           </a:xfrm>
           <a:prstGeom prst="ellipse">
@@ -11917,13 +11875,13 @@
       </p:sp>
       <p:sp>
         <p:nvSpPr>
-          <p:cNvPr id="27" name="Text 25"/>
-          <p:cNvSpPr/>
-          <p:nvPr/>
-        </p:nvSpPr>
-        <p:spPr>
-          <a:xfrm>
-            <a:off x="7086600" y="4389120"/>
+          <p:cNvPr id="26" name="Text 24"/>
+          <p:cNvSpPr/>
+          <p:nvPr/>
+        </p:nvSpPr>
+        <p:spPr>
+          <a:xfrm>
+            <a:off x="7086600" y="3986784"/>
             <a:ext cx="4389120" cy="420624"/>
           </a:xfrm>
           <a:prstGeom prst="rect">
@@ -11948,7 +11906,7 @@
                 <a:ea typeface="Calibri" pitchFamily="34" charset="-122"/>
                 <a:cs typeface="Calibri" pitchFamily="34" charset="-120"/>
               </a:rPr>
-              <a:t>gestionnaire — portefeuille par responsable</a:t>
+              <a:t>4 vues V_BI_* : production, effectifs, clients, présence</a:t>
             </a:r>
             <a:endParaRPr lang="en-US" sz="1150" dirty="0"/>
           </a:p>
@@ -11956,13 +11914,13 @@
       </p:sp>
       <p:sp>
         <p:nvSpPr>
-          <p:cNvPr id="28" name="Shape 26"/>
-          <p:cNvSpPr/>
-          <p:nvPr/>
-        </p:nvSpPr>
-        <p:spPr>
-          <a:xfrm>
-            <a:off x="6812280" y="4992624"/>
+          <p:cNvPr id="27" name="Shape 25"/>
+          <p:cNvSpPr/>
+          <p:nvPr/>
+        </p:nvSpPr>
+        <p:spPr>
+          <a:xfrm>
+            <a:off x="6812280" y="4590288"/>
             <a:ext cx="109728" cy="109728"/>
           </a:xfrm>
           <a:prstGeom prst="ellipse">
@@ -11981,13 +11939,13 @@
       </p:sp>
       <p:sp>
         <p:nvSpPr>
-          <p:cNvPr id="29" name="Text 27"/>
-          <p:cNvSpPr/>
-          <p:nvPr/>
-        </p:nvSpPr>
-        <p:spPr>
-          <a:xfrm>
-            <a:off x="7086600" y="4846320"/>
+          <p:cNvPr id="28" name="Text 26"/>
+          <p:cNvSpPr/>
+          <p:nvPr/>
+        </p:nvSpPr>
+        <p:spPr>
+          <a:xfrm>
+            <a:off x="7086600" y="4443984"/>
             <a:ext cx="4389120" cy="420624"/>
           </a:xfrm>
           <a:prstGeom prst="rect">
@@ -12012,7 +11970,71 @@
                 <a:ea typeface="Calibri" pitchFamily="34" charset="-122"/>
                 <a:cs typeface="Calibri" pitchFamily="34" charset="-120"/>
               </a:rPr>
-              <a:t>type_client — particulier, société, entreprise</a:t>
+              <a:t>Dimensions conformes AGENCE (SK_AGENCE) et B_UTILISATEURS (SK_UTILISATEUR)</a:t>
+            </a:r>
+            <a:endParaRPr lang="en-US" sz="1150" dirty="0"/>
+          </a:p>
+        </p:txBody>
+      </p:sp>
+      <p:sp>
+        <p:nvSpPr>
+          <p:cNvPr id="29" name="Shape 27"/>
+          <p:cNvSpPr/>
+          <p:nvPr/>
+        </p:nvSpPr>
+        <p:spPr>
+          <a:xfrm>
+            <a:off x="6812280" y="5047488"/>
+            <a:ext cx="109728" cy="109728"/>
+          </a:xfrm>
+          <a:prstGeom prst="ellipse">
+            <a:avLst/>
+          </a:prstGeom>
+          <a:solidFill>
+            <a:srgbClr val="3C6FC3"/>
+          </a:solidFill>
+          <a:ln w="12700">
+            <a:solidFill>
+              <a:srgbClr val="3C6FC3"/>
+            </a:solidFill>
+            <a:prstDash val="solid"/>
+          </a:ln>
+        </p:spPr>
+      </p:sp>
+      <p:sp>
+        <p:nvSpPr>
+          <p:cNvPr id="30" name="Text 28"/>
+          <p:cNvSpPr/>
+          <p:nvPr/>
+        </p:nvSpPr>
+        <p:spPr>
+          <a:xfrm>
+            <a:off x="7086600" y="4901184"/>
+            <a:ext cx="4389120" cy="420624"/>
+          </a:xfrm>
+          <a:prstGeom prst="rect">
+            <a:avLst/>
+          </a:prstGeom>
+          <a:noFill/>
+          <a:ln/>
+        </p:spPr>
+        <p:txBody>
+          <a:bodyPr wrap="square" lIns="0" tIns="0" rIns="0" bIns="0" rtlCol="0" anchor="ctr"/>
+          <a:lstStyle/>
+          <a:p>
+            <a:pPr indent="0" marL="0">
+              <a:buNone/>
+            </a:pPr>
+            <a:r>
+              <a:rPr lang="en-US" sz="1150" dirty="0">
+                <a:solidFill>
+                  <a:srgbClr val="1B2A44"/>
+                </a:solidFill>
+                <a:latin typeface="Calibri" pitchFamily="34" charset="0"/>
+                <a:ea typeface="Calibri" pitchFamily="34" charset="-122"/>
+                <a:cs typeface="Calibri" pitchFamily="34" charset="-120"/>
+              </a:rPr>
+              <a:t>Période et type de client : dimensions dégénérées portées par les vues</a:t>
             </a:r>
             <a:endParaRPr lang="en-US" sz="1150" dirty="0"/>
           </a:p>
@@ -13870,7 +13892,7 @@
                 <a:ea typeface="Calibri" pitchFamily="34" charset="-122"/>
                 <a:cs typeface="Calibri" pitchFamily="34" charset="-120"/>
               </a:rPr>
-              <a:t>Fusion des sources sur la clé SK_AGENCE</a:t>
+              <a:t>Fusion sur SK_AGENCE, puis regroupement sur SK_UTILISATEUR</a:t>
             </a:r>
             <a:endParaRPr lang="en-US" sz="1100" dirty="0"/>
           </a:p>
@@ -14184,7 +14206,7 @@
                 <a:ea typeface="Consolas" pitchFamily="34" charset="-122"/>
                 <a:cs typeface="Consolas" pitchFamily="34" charset="-120"/>
               </a:rPr>
-              <a:t>AGENCE · B_UTILISATEURS · B_CLIENTS</a:t>
+              <a:t>AGENCE · B_UTILISATEURS · CLIENT_BTK</a:t>
             </a:r>
             <a:endParaRPr lang="en-US" sz="1150" dirty="0"/>
           </a:p>
@@ -14329,7 +14351,7 @@
                 <a:ea typeface="Georgia" pitchFamily="34" charset="-122"/>
                 <a:cs typeface="Georgia" pitchFamily="34" charset="-120"/>
               </a:rPr>
-              <a:t>45</a:t>
+              <a:t>49</a:t>
             </a:r>
             <a:endParaRPr lang="en-US" sz="2600" dirty="0"/>
           </a:p>
@@ -14368,7 +14390,7 @@
                 <a:ea typeface="Calibri" pitchFamily="34" charset="-122"/>
                 <a:cs typeface="Calibri" pitchFamily="34" charset="-120"/>
               </a:rPr>
-              <a:t>agences consolidées</a:t>
+              <a:t>entités consolidées</a:t>
             </a:r>
             <a:endParaRPr lang="en-US" sz="1150" dirty="0"/>
           </a:p>

</xml_diff>

<commit_message>
Slide du diagramme de cas d'utilisation refait pour l'ecran
- Nouvelle version large du diagramme (clustering/gen_uc_slide.py) : memes
  acteurs, memes 13 cas et memes relations <<include>> que la figure 2.1,
  mais bulles allongees, libelles sur une seule ligne et typographie
  nettement plus grande
- Ratio 2,1 adapte au format 16:9 : le diagramme occupe toute la largeur du
  slide au lieu d'etre ecrase dans une demi-colonne
- Fond aligne sur celui des slides, panneau lateral remplace par une ligne
  de synthese (13 cas / 5 cas / 3 cas)
- La figure 2.1 du rapport reste inchangee
</commit_message>
<xml_diff>
--- a/presentation/Soutenance_PFE_Oussema_Korbosli.pptx
+++ b/presentation/Soutenance_PFE_Oussema_Korbosli.pptx
@@ -10647,9 +10647,48 @@
           </a:p>
         </p:txBody>
       </p:sp>
+      <p:sp>
+        <p:nvSpPr>
+          <p:cNvPr id="7" name="Text 5"/>
+          <p:cNvSpPr/>
+          <p:nvPr/>
+        </p:nvSpPr>
+        <p:spPr>
+          <a:xfrm>
+            <a:off x="566928" y="1115568"/>
+            <a:ext cx="11064240" cy="475488"/>
+          </a:xfrm>
+          <a:prstGeom prst="rect">
+            <a:avLst/>
+          </a:prstGeom>
+          <a:noFill/>
+          <a:ln/>
+        </p:spPr>
+        <p:txBody>
+          <a:bodyPr wrap="square" lIns="0" tIns="0" rIns="0" bIns="0" rtlCol="0" anchor="ctr"/>
+          <a:lstStyle/>
+          <a:p>
+            <a:pPr algn="ctr" indent="0" marL="0">
+              <a:buNone/>
+            </a:pPr>
+            <a:r>
+              <a:rPr lang="en-US" sz="1350" dirty="0">
+                <a:solidFill>
+                  <a:srgbClr val="1B2A44"/>
+                </a:solidFill>
+                <a:latin typeface="Calibri" pitchFamily="34" charset="0"/>
+                <a:ea typeface="Calibri" pitchFamily="34" charset="-122"/>
+                <a:cs typeface="Calibri" pitchFamily="34" charset="-120"/>
+              </a:rPr>
+              <a:t>Administrateur : les 13 cas   ·   Directeur commercial : 5 cas   ·   Utilisateur : 3 cas   ·   chaque cas inclut « S'authentifier »</a:t>
+            </a:r>
+            <a:endParaRPr lang="en-US" sz="1350" dirty="0"/>
+          </a:p>
+        </p:txBody>
+      </p:sp>
       <p:pic>
         <p:nvPicPr>
-          <p:cNvPr id="7" name="Image 0" descr="/home/user/oussema_korbosli/rapport-latex/diagrams/uc_global.png">    </p:cNvPr>
+          <p:cNvPr id="8" name="Image 0" descr="/home/user/oussema_korbosli/presentation/uc_global_slide.png">    </p:cNvPr>
           <p:cNvPicPr>
             <a:picLocks noChangeAspect="1"/>
           </p:cNvPicPr>
@@ -10663,373 +10702,14 @@
         </p:blipFill>
         <p:spPr>
           <a:xfrm>
-            <a:off x="1514819" y="1298448"/>
-            <a:ext cx="5968058" cy="4846320"/>
+            <a:off x="1149342" y="1645920"/>
+            <a:ext cx="9899411" cy="4681728"/>
           </a:xfrm>
           <a:prstGeom prst="rect">
             <a:avLst/>
           </a:prstGeom>
         </p:spPr>
       </p:pic>
-      <p:sp>
-        <p:nvSpPr>
-          <p:cNvPr id="8" name="Text 5"/>
-          <p:cNvSpPr/>
-          <p:nvPr/>
-        </p:nvSpPr>
-        <p:spPr>
-          <a:xfrm>
-            <a:off x="8641080" y="1572768"/>
-            <a:ext cx="3017520" cy="274320"/>
-          </a:xfrm>
-          <a:prstGeom prst="rect">
-            <a:avLst/>
-          </a:prstGeom>
-          <a:noFill/>
-          <a:ln/>
-        </p:spPr>
-        <p:txBody>
-          <a:bodyPr wrap="square" lIns="0" tIns="0" rIns="0" bIns="0" rtlCol="0" anchor="ctr"/>
-          <a:lstStyle/>
-          <a:p>
-            <a:pPr indent="0" marL="0">
-              <a:buNone/>
-            </a:pPr>
-            <a:r>
-              <a:rPr lang="en-US" sz="1050" b="1" spc="200" kern="0" dirty="0">
-                <a:solidFill>
-                  <a:srgbClr val="3C6FC3"/>
-                </a:solidFill>
-                <a:latin typeface="Calibri" pitchFamily="34" charset="0"/>
-                <a:ea typeface="Calibri" pitchFamily="34" charset="-122"/>
-                <a:cs typeface="Calibri" pitchFamily="34" charset="-120"/>
-              </a:rPr>
-              <a:t>LECTURE DU DIAGRAMME</a:t>
-            </a:r>
-            <a:endParaRPr lang="en-US" sz="1050" dirty="0"/>
-          </a:p>
-        </p:txBody>
-      </p:sp>
-      <p:sp>
-        <p:nvSpPr>
-          <p:cNvPr id="9" name="Shape 6"/>
-          <p:cNvSpPr/>
-          <p:nvPr/>
-        </p:nvSpPr>
-        <p:spPr>
-          <a:xfrm>
-            <a:off x="8641080" y="2048256"/>
-            <a:ext cx="109728" cy="109728"/>
-          </a:xfrm>
-          <a:prstGeom prst="ellipse">
-            <a:avLst/>
-          </a:prstGeom>
-          <a:solidFill>
-            <a:srgbClr val="3C6FC3"/>
-          </a:solidFill>
-          <a:ln w="12700">
-            <a:solidFill>
-              <a:srgbClr val="3C6FC3"/>
-            </a:solidFill>
-            <a:prstDash val="solid"/>
-          </a:ln>
-        </p:spPr>
-      </p:sp>
-      <p:sp>
-        <p:nvSpPr>
-          <p:cNvPr id="10" name="Text 7"/>
-          <p:cNvSpPr/>
-          <p:nvPr/>
-        </p:nvSpPr>
-        <p:spPr>
-          <a:xfrm>
-            <a:off x="8915400" y="1901952"/>
-            <a:ext cx="2743200" cy="420624"/>
-          </a:xfrm>
-          <a:prstGeom prst="rect">
-            <a:avLst/>
-          </a:prstGeom>
-          <a:noFill/>
-          <a:ln/>
-        </p:spPr>
-        <p:txBody>
-          <a:bodyPr wrap="square" lIns="0" tIns="0" rIns="0" bIns="0" rtlCol="0" anchor="ctr"/>
-          <a:lstStyle/>
-          <a:p>
-            <a:pPr indent="0" marL="0">
-              <a:buNone/>
-            </a:pPr>
-            <a:r>
-              <a:rPr lang="en-US" sz="1150" dirty="0">
-                <a:solidFill>
-                  <a:srgbClr val="1B2A44"/>
-                </a:solidFill>
-                <a:latin typeface="Calibri" pitchFamily="34" charset="0"/>
-                <a:ea typeface="Calibri" pitchFamily="34" charset="-122"/>
-                <a:cs typeface="Calibri" pitchFamily="34" charset="-120"/>
-              </a:rPr>
-              <a:t>Trois acteurs, treize cas d'utilisation</a:t>
-            </a:r>
-            <a:endParaRPr lang="en-US" sz="1150" dirty="0"/>
-          </a:p>
-        </p:txBody>
-      </p:sp>
-      <p:sp>
-        <p:nvSpPr>
-          <p:cNvPr id="11" name="Shape 8"/>
-          <p:cNvSpPr/>
-          <p:nvPr/>
-        </p:nvSpPr>
-        <p:spPr>
-          <a:xfrm>
-            <a:off x="8641080" y="2505456"/>
-            <a:ext cx="109728" cy="109728"/>
-          </a:xfrm>
-          <a:prstGeom prst="ellipse">
-            <a:avLst/>
-          </a:prstGeom>
-          <a:solidFill>
-            <a:srgbClr val="3C6FC3"/>
-          </a:solidFill>
-          <a:ln w="12700">
-            <a:solidFill>
-              <a:srgbClr val="3C6FC3"/>
-            </a:solidFill>
-            <a:prstDash val="solid"/>
-          </a:ln>
-        </p:spPr>
-      </p:sp>
-      <p:sp>
-        <p:nvSpPr>
-          <p:cNvPr id="12" name="Text 9"/>
-          <p:cNvSpPr/>
-          <p:nvPr/>
-        </p:nvSpPr>
-        <p:spPr>
-          <a:xfrm>
-            <a:off x="8915400" y="2359152"/>
-            <a:ext cx="2743200" cy="420624"/>
-          </a:xfrm>
-          <a:prstGeom prst="rect">
-            <a:avLst/>
-          </a:prstGeom>
-          <a:noFill/>
-          <a:ln/>
-        </p:spPr>
-        <p:txBody>
-          <a:bodyPr wrap="square" lIns="0" tIns="0" rIns="0" bIns="0" rtlCol="0" anchor="ctr"/>
-          <a:lstStyle/>
-          <a:p>
-            <a:pPr indent="0" marL="0">
-              <a:buNone/>
-            </a:pPr>
-            <a:r>
-              <a:rPr lang="en-US" sz="1150" dirty="0">
-                <a:solidFill>
-                  <a:srgbClr val="1B2A44"/>
-                </a:solidFill>
-                <a:latin typeface="Calibri" pitchFamily="34" charset="0"/>
-                <a:ea typeface="Calibri" pitchFamily="34" charset="-122"/>
-                <a:cs typeface="Calibri" pitchFamily="34" charset="-120"/>
-              </a:rPr>
-              <a:t>Chaque cas inclut « S'authentifier » (include)</a:t>
-            </a:r>
-            <a:endParaRPr lang="en-US" sz="1150" dirty="0"/>
-          </a:p>
-        </p:txBody>
-      </p:sp>
-      <p:sp>
-        <p:nvSpPr>
-          <p:cNvPr id="13" name="Shape 10"/>
-          <p:cNvSpPr/>
-          <p:nvPr/>
-        </p:nvSpPr>
-        <p:spPr>
-          <a:xfrm>
-            <a:off x="8641080" y="2962656"/>
-            <a:ext cx="109728" cy="109728"/>
-          </a:xfrm>
-          <a:prstGeom prst="ellipse">
-            <a:avLst/>
-          </a:prstGeom>
-          <a:solidFill>
-            <a:srgbClr val="3C6FC3"/>
-          </a:solidFill>
-          <a:ln w="12700">
-            <a:solidFill>
-              <a:srgbClr val="3C6FC3"/>
-            </a:solidFill>
-            <a:prstDash val="solid"/>
-          </a:ln>
-        </p:spPr>
-      </p:sp>
-      <p:sp>
-        <p:nvSpPr>
-          <p:cNvPr id="14" name="Text 11"/>
-          <p:cNvSpPr/>
-          <p:nvPr/>
-        </p:nvSpPr>
-        <p:spPr>
-          <a:xfrm>
-            <a:off x="8915400" y="2816352"/>
-            <a:ext cx="2743200" cy="420624"/>
-          </a:xfrm>
-          <a:prstGeom prst="rect">
-            <a:avLst/>
-          </a:prstGeom>
-          <a:noFill/>
-          <a:ln/>
-        </p:spPr>
-        <p:txBody>
-          <a:bodyPr wrap="square" lIns="0" tIns="0" rIns="0" bIns="0" rtlCol="0" anchor="ctr"/>
-          <a:lstStyle/>
-          <a:p>
-            <a:pPr indent="0" marL="0">
-              <a:buNone/>
-            </a:pPr>
-            <a:r>
-              <a:rPr lang="en-US" sz="1150" dirty="0">
-                <a:solidFill>
-                  <a:srgbClr val="1B2A44"/>
-                </a:solidFill>
-                <a:latin typeface="Calibri" pitchFamily="34" charset="0"/>
-                <a:ea typeface="Calibri" pitchFamily="34" charset="-122"/>
-                <a:cs typeface="Calibri" pitchFamily="34" charset="-120"/>
-              </a:rPr>
-              <a:t>Administrateur : les 13 cas, sans exception</a:t>
-            </a:r>
-            <a:endParaRPr lang="en-US" sz="1150" dirty="0"/>
-          </a:p>
-        </p:txBody>
-      </p:sp>
-      <p:sp>
-        <p:nvSpPr>
-          <p:cNvPr id="15" name="Shape 12"/>
-          <p:cNvSpPr/>
-          <p:nvPr/>
-        </p:nvSpPr>
-        <p:spPr>
-          <a:xfrm>
-            <a:off x="8641080" y="3419856"/>
-            <a:ext cx="109728" cy="109728"/>
-          </a:xfrm>
-          <a:prstGeom prst="ellipse">
-            <a:avLst/>
-          </a:prstGeom>
-          <a:solidFill>
-            <a:srgbClr val="3C6FC3"/>
-          </a:solidFill>
-          <a:ln w="12700">
-            <a:solidFill>
-              <a:srgbClr val="3C6FC3"/>
-            </a:solidFill>
-            <a:prstDash val="solid"/>
-          </a:ln>
-        </p:spPr>
-      </p:sp>
-      <p:sp>
-        <p:nvSpPr>
-          <p:cNvPr id="16" name="Text 13"/>
-          <p:cNvSpPr/>
-          <p:nvPr/>
-        </p:nvSpPr>
-        <p:spPr>
-          <a:xfrm>
-            <a:off x="8915400" y="3273552"/>
-            <a:ext cx="2743200" cy="420624"/>
-          </a:xfrm>
-          <a:prstGeom prst="rect">
-            <a:avLst/>
-          </a:prstGeom>
-          <a:noFill/>
-          <a:ln/>
-        </p:spPr>
-        <p:txBody>
-          <a:bodyPr wrap="square" lIns="0" tIns="0" rIns="0" bIns="0" rtlCol="0" anchor="ctr"/>
-          <a:lstStyle/>
-          <a:p>
-            <a:pPr indent="0" marL="0">
-              <a:buNone/>
-            </a:pPr>
-            <a:r>
-              <a:rPr lang="en-US" sz="1150" dirty="0">
-                <a:solidFill>
-                  <a:srgbClr val="1B2A44"/>
-                </a:solidFill>
-                <a:latin typeface="Calibri" pitchFamily="34" charset="0"/>
-                <a:ea typeface="Calibri" pitchFamily="34" charset="-122"/>
-                <a:cs typeface="Calibri" pitchFamily="34" charset="-120"/>
-              </a:rPr>
-              <a:t>Directeur commercial : 5 cas, dont les employés en consultation</a:t>
-            </a:r>
-            <a:endParaRPr lang="en-US" sz="1150" dirty="0"/>
-          </a:p>
-        </p:txBody>
-      </p:sp>
-      <p:sp>
-        <p:nvSpPr>
-          <p:cNvPr id="17" name="Shape 14"/>
-          <p:cNvSpPr/>
-          <p:nvPr/>
-        </p:nvSpPr>
-        <p:spPr>
-          <a:xfrm>
-            <a:off x="8641080" y="3877056"/>
-            <a:ext cx="109728" cy="109728"/>
-          </a:xfrm>
-          <a:prstGeom prst="ellipse">
-            <a:avLst/>
-          </a:prstGeom>
-          <a:solidFill>
-            <a:srgbClr val="3C6FC3"/>
-          </a:solidFill>
-          <a:ln w="12700">
-            <a:solidFill>
-              <a:srgbClr val="3C6FC3"/>
-            </a:solidFill>
-            <a:prstDash val="solid"/>
-          </a:ln>
-        </p:spPr>
-      </p:sp>
-      <p:sp>
-        <p:nvSpPr>
-          <p:cNvPr id="18" name="Text 15"/>
-          <p:cNvSpPr/>
-          <p:nvPr/>
-        </p:nvSpPr>
-        <p:spPr>
-          <a:xfrm>
-            <a:off x="8915400" y="3730752"/>
-            <a:ext cx="2743200" cy="420624"/>
-          </a:xfrm>
-          <a:prstGeom prst="rect">
-            <a:avLst/>
-          </a:prstGeom>
-          <a:noFill/>
-          <a:ln/>
-        </p:spPr>
-        <p:txBody>
-          <a:bodyPr wrap="square" lIns="0" tIns="0" rIns="0" bIns="0" rtlCol="0" anchor="ctr"/>
-          <a:lstStyle/>
-          <a:p>
-            <a:pPr indent="0" marL="0">
-              <a:buNone/>
-            </a:pPr>
-            <a:r>
-              <a:rPr lang="en-US" sz="1150" dirty="0">
-                <a:solidFill>
-                  <a:srgbClr val="1B2A44"/>
-                </a:solidFill>
-                <a:latin typeface="Calibri" pitchFamily="34" charset="0"/>
-                <a:ea typeface="Calibri" pitchFamily="34" charset="-122"/>
-                <a:cs typeface="Calibri" pitchFamily="34" charset="-120"/>
-              </a:rPr>
-              <a:t>Utilisateur : 3 cas — pointage, demandes, notifications</a:t>
-            </a:r>
-            <a:endParaRPr lang="en-US" sz="1150" dirty="0"/>
-          </a:p>
-        </p:txBody>
-      </p:sp>
     </p:spTree>
   </p:cSld>
   <p:clrMapOvr>

</xml_diff>

<commit_message>
Fleche << Soumettre une demande >> du directeur commercial rendue lisible
- Retour a la version precedente du diagramme dans la presentation
  (suppression de la variante large et de son script)
- La flece du directeur vers << Soumettre une demande >> ne fait plus le
  tour par le bas : elle descend le long du cote droit, passe au-dessus de
  l'utilisateur et aborde la bulle horizontalement, du meme cote que la
  flece de l'utilisateur
- Diagramme elargi (ratio 1,23 -> 1,42) : il remplit mieux la page du
  rapport et le cadre du slide
</commit_message>
<xml_diff>
--- a/presentation/Soutenance_PFE_Oussema_Korbosli.pptx
+++ b/presentation/Soutenance_PFE_Oussema_Korbosli.pptx
@@ -10647,48 +10647,9 @@
           </a:p>
         </p:txBody>
       </p:sp>
-      <p:sp>
-        <p:nvSpPr>
-          <p:cNvPr id="7" name="Text 5"/>
-          <p:cNvSpPr/>
-          <p:nvPr/>
-        </p:nvSpPr>
-        <p:spPr>
-          <a:xfrm>
-            <a:off x="566928" y="1115568"/>
-            <a:ext cx="11064240" cy="475488"/>
-          </a:xfrm>
-          <a:prstGeom prst="rect">
-            <a:avLst/>
-          </a:prstGeom>
-          <a:noFill/>
-          <a:ln/>
-        </p:spPr>
-        <p:txBody>
-          <a:bodyPr wrap="square" lIns="0" tIns="0" rIns="0" bIns="0" rtlCol="0" anchor="ctr"/>
-          <a:lstStyle/>
-          <a:p>
-            <a:pPr algn="ctr" indent="0" marL="0">
-              <a:buNone/>
-            </a:pPr>
-            <a:r>
-              <a:rPr lang="en-US" sz="1350" dirty="0">
-                <a:solidFill>
-                  <a:srgbClr val="1B2A44"/>
-                </a:solidFill>
-                <a:latin typeface="Calibri" pitchFamily="34" charset="0"/>
-                <a:ea typeface="Calibri" pitchFamily="34" charset="-122"/>
-                <a:cs typeface="Calibri" pitchFamily="34" charset="-120"/>
-              </a:rPr>
-              <a:t>Administrateur : les 13 cas   ·   Directeur commercial : 5 cas   ·   Utilisateur : 3 cas   ·   chaque cas inclut « S'authentifier »</a:t>
-            </a:r>
-            <a:endParaRPr lang="en-US" sz="1350" dirty="0"/>
-          </a:p>
-        </p:txBody>
-      </p:sp>
       <p:pic>
         <p:nvPicPr>
-          <p:cNvPr id="8" name="Image 0" descr="/home/user/oussema_korbosli/presentation/uc_global_slide.png">    </p:cNvPr>
+          <p:cNvPr id="7" name="Image 0" descr="/home/user/oussema_korbosli/rapport-latex/diagrams/uc_global.png">    </p:cNvPr>
           <p:cNvPicPr>
             <a:picLocks noChangeAspect="1"/>
           </p:cNvPicPr>
@@ -10702,14 +10663,373 @@
         </p:blipFill>
         <p:spPr>
           <a:xfrm>
-            <a:off x="1149342" y="1645920"/>
-            <a:ext cx="9899411" cy="4681728"/>
+            <a:off x="1056006" y="1298448"/>
+            <a:ext cx="6885683" cy="4846320"/>
           </a:xfrm>
           <a:prstGeom prst="rect">
             <a:avLst/>
           </a:prstGeom>
         </p:spPr>
       </p:pic>
+      <p:sp>
+        <p:nvSpPr>
+          <p:cNvPr id="8" name="Text 5"/>
+          <p:cNvSpPr/>
+          <p:nvPr/>
+        </p:nvSpPr>
+        <p:spPr>
+          <a:xfrm>
+            <a:off x="8641080" y="1572768"/>
+            <a:ext cx="3017520" cy="274320"/>
+          </a:xfrm>
+          <a:prstGeom prst="rect">
+            <a:avLst/>
+          </a:prstGeom>
+          <a:noFill/>
+          <a:ln/>
+        </p:spPr>
+        <p:txBody>
+          <a:bodyPr wrap="square" lIns="0" tIns="0" rIns="0" bIns="0" rtlCol="0" anchor="ctr"/>
+          <a:lstStyle/>
+          <a:p>
+            <a:pPr indent="0" marL="0">
+              <a:buNone/>
+            </a:pPr>
+            <a:r>
+              <a:rPr lang="en-US" sz="1050" b="1" spc="200" kern="0" dirty="0">
+                <a:solidFill>
+                  <a:srgbClr val="3C6FC3"/>
+                </a:solidFill>
+                <a:latin typeface="Calibri" pitchFamily="34" charset="0"/>
+                <a:ea typeface="Calibri" pitchFamily="34" charset="-122"/>
+                <a:cs typeface="Calibri" pitchFamily="34" charset="-120"/>
+              </a:rPr>
+              <a:t>LECTURE DU DIAGRAMME</a:t>
+            </a:r>
+            <a:endParaRPr lang="en-US" sz="1050" dirty="0"/>
+          </a:p>
+        </p:txBody>
+      </p:sp>
+      <p:sp>
+        <p:nvSpPr>
+          <p:cNvPr id="9" name="Shape 6"/>
+          <p:cNvSpPr/>
+          <p:nvPr/>
+        </p:nvSpPr>
+        <p:spPr>
+          <a:xfrm>
+            <a:off x="8641080" y="2048256"/>
+            <a:ext cx="109728" cy="109728"/>
+          </a:xfrm>
+          <a:prstGeom prst="ellipse">
+            <a:avLst/>
+          </a:prstGeom>
+          <a:solidFill>
+            <a:srgbClr val="3C6FC3"/>
+          </a:solidFill>
+          <a:ln w="12700">
+            <a:solidFill>
+              <a:srgbClr val="3C6FC3"/>
+            </a:solidFill>
+            <a:prstDash val="solid"/>
+          </a:ln>
+        </p:spPr>
+      </p:sp>
+      <p:sp>
+        <p:nvSpPr>
+          <p:cNvPr id="10" name="Text 7"/>
+          <p:cNvSpPr/>
+          <p:nvPr/>
+        </p:nvSpPr>
+        <p:spPr>
+          <a:xfrm>
+            <a:off x="8915400" y="1901952"/>
+            <a:ext cx="2743200" cy="420624"/>
+          </a:xfrm>
+          <a:prstGeom prst="rect">
+            <a:avLst/>
+          </a:prstGeom>
+          <a:noFill/>
+          <a:ln/>
+        </p:spPr>
+        <p:txBody>
+          <a:bodyPr wrap="square" lIns="0" tIns="0" rIns="0" bIns="0" rtlCol="0" anchor="ctr"/>
+          <a:lstStyle/>
+          <a:p>
+            <a:pPr indent="0" marL="0">
+              <a:buNone/>
+            </a:pPr>
+            <a:r>
+              <a:rPr lang="en-US" sz="1150" dirty="0">
+                <a:solidFill>
+                  <a:srgbClr val="1B2A44"/>
+                </a:solidFill>
+                <a:latin typeface="Calibri" pitchFamily="34" charset="0"/>
+                <a:ea typeface="Calibri" pitchFamily="34" charset="-122"/>
+                <a:cs typeface="Calibri" pitchFamily="34" charset="-120"/>
+              </a:rPr>
+              <a:t>Trois acteurs, treize cas d'utilisation</a:t>
+            </a:r>
+            <a:endParaRPr lang="en-US" sz="1150" dirty="0"/>
+          </a:p>
+        </p:txBody>
+      </p:sp>
+      <p:sp>
+        <p:nvSpPr>
+          <p:cNvPr id="11" name="Shape 8"/>
+          <p:cNvSpPr/>
+          <p:nvPr/>
+        </p:nvSpPr>
+        <p:spPr>
+          <a:xfrm>
+            <a:off x="8641080" y="2505456"/>
+            <a:ext cx="109728" cy="109728"/>
+          </a:xfrm>
+          <a:prstGeom prst="ellipse">
+            <a:avLst/>
+          </a:prstGeom>
+          <a:solidFill>
+            <a:srgbClr val="3C6FC3"/>
+          </a:solidFill>
+          <a:ln w="12700">
+            <a:solidFill>
+              <a:srgbClr val="3C6FC3"/>
+            </a:solidFill>
+            <a:prstDash val="solid"/>
+          </a:ln>
+        </p:spPr>
+      </p:sp>
+      <p:sp>
+        <p:nvSpPr>
+          <p:cNvPr id="12" name="Text 9"/>
+          <p:cNvSpPr/>
+          <p:nvPr/>
+        </p:nvSpPr>
+        <p:spPr>
+          <a:xfrm>
+            <a:off x="8915400" y="2359152"/>
+            <a:ext cx="2743200" cy="420624"/>
+          </a:xfrm>
+          <a:prstGeom prst="rect">
+            <a:avLst/>
+          </a:prstGeom>
+          <a:noFill/>
+          <a:ln/>
+        </p:spPr>
+        <p:txBody>
+          <a:bodyPr wrap="square" lIns="0" tIns="0" rIns="0" bIns="0" rtlCol="0" anchor="ctr"/>
+          <a:lstStyle/>
+          <a:p>
+            <a:pPr indent="0" marL="0">
+              <a:buNone/>
+            </a:pPr>
+            <a:r>
+              <a:rPr lang="en-US" sz="1150" dirty="0">
+                <a:solidFill>
+                  <a:srgbClr val="1B2A44"/>
+                </a:solidFill>
+                <a:latin typeface="Calibri" pitchFamily="34" charset="0"/>
+                <a:ea typeface="Calibri" pitchFamily="34" charset="-122"/>
+                <a:cs typeface="Calibri" pitchFamily="34" charset="-120"/>
+              </a:rPr>
+              <a:t>Chaque cas inclut « S'authentifier » (include)</a:t>
+            </a:r>
+            <a:endParaRPr lang="en-US" sz="1150" dirty="0"/>
+          </a:p>
+        </p:txBody>
+      </p:sp>
+      <p:sp>
+        <p:nvSpPr>
+          <p:cNvPr id="13" name="Shape 10"/>
+          <p:cNvSpPr/>
+          <p:nvPr/>
+        </p:nvSpPr>
+        <p:spPr>
+          <a:xfrm>
+            <a:off x="8641080" y="2962656"/>
+            <a:ext cx="109728" cy="109728"/>
+          </a:xfrm>
+          <a:prstGeom prst="ellipse">
+            <a:avLst/>
+          </a:prstGeom>
+          <a:solidFill>
+            <a:srgbClr val="3C6FC3"/>
+          </a:solidFill>
+          <a:ln w="12700">
+            <a:solidFill>
+              <a:srgbClr val="3C6FC3"/>
+            </a:solidFill>
+            <a:prstDash val="solid"/>
+          </a:ln>
+        </p:spPr>
+      </p:sp>
+      <p:sp>
+        <p:nvSpPr>
+          <p:cNvPr id="14" name="Text 11"/>
+          <p:cNvSpPr/>
+          <p:nvPr/>
+        </p:nvSpPr>
+        <p:spPr>
+          <a:xfrm>
+            <a:off x="8915400" y="2816352"/>
+            <a:ext cx="2743200" cy="420624"/>
+          </a:xfrm>
+          <a:prstGeom prst="rect">
+            <a:avLst/>
+          </a:prstGeom>
+          <a:noFill/>
+          <a:ln/>
+        </p:spPr>
+        <p:txBody>
+          <a:bodyPr wrap="square" lIns="0" tIns="0" rIns="0" bIns="0" rtlCol="0" anchor="ctr"/>
+          <a:lstStyle/>
+          <a:p>
+            <a:pPr indent="0" marL="0">
+              <a:buNone/>
+            </a:pPr>
+            <a:r>
+              <a:rPr lang="en-US" sz="1150" dirty="0">
+                <a:solidFill>
+                  <a:srgbClr val="1B2A44"/>
+                </a:solidFill>
+                <a:latin typeface="Calibri" pitchFamily="34" charset="0"/>
+                <a:ea typeface="Calibri" pitchFamily="34" charset="-122"/>
+                <a:cs typeface="Calibri" pitchFamily="34" charset="-120"/>
+              </a:rPr>
+              <a:t>Administrateur : les 13 cas, sans exception</a:t>
+            </a:r>
+            <a:endParaRPr lang="en-US" sz="1150" dirty="0"/>
+          </a:p>
+        </p:txBody>
+      </p:sp>
+      <p:sp>
+        <p:nvSpPr>
+          <p:cNvPr id="15" name="Shape 12"/>
+          <p:cNvSpPr/>
+          <p:nvPr/>
+        </p:nvSpPr>
+        <p:spPr>
+          <a:xfrm>
+            <a:off x="8641080" y="3419856"/>
+            <a:ext cx="109728" cy="109728"/>
+          </a:xfrm>
+          <a:prstGeom prst="ellipse">
+            <a:avLst/>
+          </a:prstGeom>
+          <a:solidFill>
+            <a:srgbClr val="3C6FC3"/>
+          </a:solidFill>
+          <a:ln w="12700">
+            <a:solidFill>
+              <a:srgbClr val="3C6FC3"/>
+            </a:solidFill>
+            <a:prstDash val="solid"/>
+          </a:ln>
+        </p:spPr>
+      </p:sp>
+      <p:sp>
+        <p:nvSpPr>
+          <p:cNvPr id="16" name="Text 13"/>
+          <p:cNvSpPr/>
+          <p:nvPr/>
+        </p:nvSpPr>
+        <p:spPr>
+          <a:xfrm>
+            <a:off x="8915400" y="3273552"/>
+            <a:ext cx="2743200" cy="420624"/>
+          </a:xfrm>
+          <a:prstGeom prst="rect">
+            <a:avLst/>
+          </a:prstGeom>
+          <a:noFill/>
+          <a:ln/>
+        </p:spPr>
+        <p:txBody>
+          <a:bodyPr wrap="square" lIns="0" tIns="0" rIns="0" bIns="0" rtlCol="0" anchor="ctr"/>
+          <a:lstStyle/>
+          <a:p>
+            <a:pPr indent="0" marL="0">
+              <a:buNone/>
+            </a:pPr>
+            <a:r>
+              <a:rPr lang="en-US" sz="1150" dirty="0">
+                <a:solidFill>
+                  <a:srgbClr val="1B2A44"/>
+                </a:solidFill>
+                <a:latin typeface="Calibri" pitchFamily="34" charset="0"/>
+                <a:ea typeface="Calibri" pitchFamily="34" charset="-122"/>
+                <a:cs typeface="Calibri" pitchFamily="34" charset="-120"/>
+              </a:rPr>
+              <a:t>Directeur commercial : 5 cas, dont les employés en consultation</a:t>
+            </a:r>
+            <a:endParaRPr lang="en-US" sz="1150" dirty="0"/>
+          </a:p>
+        </p:txBody>
+      </p:sp>
+      <p:sp>
+        <p:nvSpPr>
+          <p:cNvPr id="17" name="Shape 14"/>
+          <p:cNvSpPr/>
+          <p:nvPr/>
+        </p:nvSpPr>
+        <p:spPr>
+          <a:xfrm>
+            <a:off x="8641080" y="3877056"/>
+            <a:ext cx="109728" cy="109728"/>
+          </a:xfrm>
+          <a:prstGeom prst="ellipse">
+            <a:avLst/>
+          </a:prstGeom>
+          <a:solidFill>
+            <a:srgbClr val="3C6FC3"/>
+          </a:solidFill>
+          <a:ln w="12700">
+            <a:solidFill>
+              <a:srgbClr val="3C6FC3"/>
+            </a:solidFill>
+            <a:prstDash val="solid"/>
+          </a:ln>
+        </p:spPr>
+      </p:sp>
+      <p:sp>
+        <p:nvSpPr>
+          <p:cNvPr id="18" name="Text 15"/>
+          <p:cNvSpPr/>
+          <p:nvPr/>
+        </p:nvSpPr>
+        <p:spPr>
+          <a:xfrm>
+            <a:off x="8915400" y="3730752"/>
+            <a:ext cx="2743200" cy="420624"/>
+          </a:xfrm>
+          <a:prstGeom prst="rect">
+            <a:avLst/>
+          </a:prstGeom>
+          <a:noFill/>
+          <a:ln/>
+        </p:spPr>
+        <p:txBody>
+          <a:bodyPr wrap="square" lIns="0" tIns="0" rIns="0" bIns="0" rtlCol="0" anchor="ctr"/>
+          <a:lstStyle/>
+          <a:p>
+            <a:pPr indent="0" marL="0">
+              <a:buNone/>
+            </a:pPr>
+            <a:r>
+              <a:rPr lang="en-US" sz="1150" dirty="0">
+                <a:solidFill>
+                  <a:srgbClr val="1B2A44"/>
+                </a:solidFill>
+                <a:latin typeface="Calibri" pitchFamily="34" charset="0"/>
+                <a:ea typeface="Calibri" pitchFamily="34" charset="-122"/>
+                <a:cs typeface="Calibri" pitchFamily="34" charset="-120"/>
+              </a:rPr>
+              <a:t>Utilisateur : 3 cas — pointage, demandes, notifications</a:t>
+            </a:r>
+            <a:endParaRPr lang="en-US" sz="1150" dirty="0"/>
+          </a:p>
+        </p:txBody>
+      </p:sp>
     </p:spTree>
   </p:cSld>
   <p:clrMapOvr>

</xml_diff>

<commit_message>
Acteurs regroupes a gauche du diagramme et page de garde en rouge ESB
Figure 2.1 (rapport et presentation)
- Les trois acteurs sont desormais alignes a gauche : administrateur en
  retrait, directeur commercial et utilisateur en vis-a-vis de leurs cas
- Colonne reordonnee : cas propres a l'administrateur en haut, ceux du
  directeur ensuite, ceux de l'utilisateur en bas, << Soumettre une
  demande >> a la charniere entre les deux derniers blocs
- Le faisceau <<include>> vers << S'authentifier >> est desormais totalement
  degage a droite : plus aucune association ne le traverse
- Halo blanc derriere les acteurs secondaires : les associations de
  l'administrateur passent derriere la silhouette

Page de garde
- << RAPPORT DE STAGE >> et les deux filets passent du noir au rouge Esprit
  #CE171F, releve directement sur le logo ESB, conformement au modele
</commit_message>
<xml_diff>
--- a/presentation/Soutenance_PFE_Oussema_Korbosli.pptx
+++ b/presentation/Soutenance_PFE_Oussema_Korbosli.pptx
@@ -10663,8 +10663,8 @@
         </p:blipFill>
         <p:spPr>
           <a:xfrm>
-            <a:off x="1056006" y="1298448"/>
-            <a:ext cx="6885683" cy="4846320"/>
+            <a:off x="1505216" y="1298448"/>
+            <a:ext cx="5987264" cy="4846320"/>
           </a:xfrm>
           <a:prstGeom prst="rect">
             <a:avLst/>

</xml_diff>

<commit_message>
Diagramme de cas d'utilisation : trace orthogonal et acteurs espaces
- Les associations ne rayonnent plus depuis un point unique : chaque acteur
  dispose de son propre couloir vertical et les traces sont a angle droit
- Couloir de l'administrateur place au plus pres des cas : ses treize
  associations ne croisent plus aucune autre
- Les acteurs sont nettement espaces verticalement (administrateur en haut,
  directeur commercial au milieu, utilisateur en bas)
- Quand plusieurs acteurs partagent un cas, les fleches arrivent a des
  hauteurs decalees : chaque pointe reste distincte
- Le faisceau <<include>> reste degage a droite, aucune association ne le
  traverse
- Proportions revues (ratio 1,29) pour occuper toute la largeur de la page
</commit_message>
<xml_diff>
--- a/presentation/Soutenance_PFE_Oussema_Korbosli.pptx
+++ b/presentation/Soutenance_PFE_Oussema_Korbosli.pptx
@@ -10663,8 +10663,8 @@
         </p:blipFill>
         <p:spPr>
           <a:xfrm>
-            <a:off x="1505216" y="1298448"/>
-            <a:ext cx="5987264" cy="4846320"/>
+            <a:off x="1379632" y="1298448"/>
+            <a:ext cx="6238431" cy="4846320"/>
           </a:xfrm>
           <a:prstGeom prst="rect">
             <a:avLst/>

</xml_diff>

<commit_message>
Figure 2.1 : retour au rendu PlantUML, sans bulle de note
- diagramme regénéré avec PlantUML (forme demandée) : les trois acteurs
  sont regroupés à gauche, aucune note UML n'apparaît ;
- associations conservées telles que validées : administrateur sur les 13
  cas, directeur commercial sur 5 cas (dont « Gérer les employés » en
  consultation), utilisateur sur 3 cas ; chaque cas inclut « S'authentifier » ;
- polices agrandies et espacement des rangs réduit pour rester lisible une
  fois la figure ramenée à la largeur du texte ;
- figure redressée dans le rapport (le rendu est désormais quasi carré, la
  rotation de 90° n'apportait plus de gain de taille) ;
- diapositive 18 de la soutenance mise à jour avec le même rendu.

Co-Authored-By: Claude Opus 5 <noreply@anthropic.com>
Claude-Session: https://claude.ai/code/session_01XrCEv79rD628gYBfC2XWx6
</commit_message>
<xml_diff>
--- a/presentation/Soutenance_PFE_Oussema_Korbosli.pptx
+++ b/presentation/Soutenance_PFE_Oussema_Korbosli.pptx
@@ -10663,8 +10663,8 @@
         </p:blipFill>
         <p:spPr>
           <a:xfrm>
-            <a:off x="1379632" y="1298448"/>
-            <a:ext cx="6238431" cy="4846320"/>
+            <a:off x="1961492" y="1188720"/>
+            <a:ext cx="5074713" cy="5175504"/>
           </a:xfrm>
           <a:prstGeom prst="rect">
             <a:avLst/>

</xml_diff>

<commit_message>
Figure 2.1 : administrateur en haut a gauche, figure seule sur sa page
- le rendu n'est plus produit par graphviz : celui-ci place toujours au
  centre l'acteur relie aux treize cas, alors que l'administrateur doit
  figurer en tete ; le trace est donc repris par gen_uc_global.py, qui
  reproduit la meme presentation avec un placement maitrise ;
- acteurs alignes a gauche dans l'ordre administrateur, directeur
  commercial, utilisateur, chacun a la hauteur moyenne de ses cas ;
- notation UML respectee : les associations acteur-cas sont de simples
  traits, sans pointe de fleche ; seules les dependances «include»
  portent une fleche ouverte en pointilles ;
- aucune bulle de note ;
- la figure occupe desormais une page entiere a elle seule ;
- diapositive 18 de la soutenance mise a jour et remise en page pour le
  format portrait du diagramme.

Co-Authored-By: Claude Opus 5 <noreply@anthropic.com>
Claude-Session: https://claude.ai/code/session_01XrCEv79rD628gYBfC2XWx6
</commit_message>
<xml_diff>
--- a/presentation/Soutenance_PFE_Oussema_Korbosli.pptx
+++ b/presentation/Soutenance_PFE_Oussema_Korbosli.pptx
@@ -10663,8 +10663,8 @@
         </p:blipFill>
         <p:spPr>
           <a:xfrm>
-            <a:off x="1961492" y="1188720"/>
-            <a:ext cx="5074713" cy="5175504"/>
+            <a:off x="1298904" y="1170432"/>
+            <a:ext cx="3985873" cy="5212080"/>
           </a:xfrm>
           <a:prstGeom prst="rect">
             <a:avLst/>
@@ -10679,8 +10679,8 @@
         </p:nvSpPr>
         <p:spPr>
           <a:xfrm>
-            <a:off x="8641080" y="1572768"/>
-            <a:ext cx="3017520" cy="274320"/>
+            <a:off x="6446520" y="1700784"/>
+            <a:ext cx="5120640" cy="274320"/>
           </a:xfrm>
           <a:prstGeom prst="rect">
             <a:avLst/>
@@ -10718,7 +10718,7 @@
         </p:nvSpPr>
         <p:spPr>
           <a:xfrm>
-            <a:off x="8641080" y="2048256"/>
+            <a:off x="6446520" y="2231136"/>
             <a:ext cx="109728" cy="109728"/>
           </a:xfrm>
           <a:prstGeom prst="ellipse">
@@ -10743,8 +10743,8 @@
         </p:nvSpPr>
         <p:spPr>
           <a:xfrm>
-            <a:off x="8915400" y="1901952"/>
-            <a:ext cx="2743200" cy="420624"/>
+            <a:off x="6720840" y="2084832"/>
+            <a:ext cx="4846320" cy="420624"/>
           </a:xfrm>
           <a:prstGeom prst="rect">
             <a:avLst/>
@@ -10760,7 +10760,7 @@
               <a:buNone/>
             </a:pPr>
             <a:r>
-              <a:rPr lang="en-US" sz="1150" dirty="0">
+              <a:rPr lang="en-US" sz="1300" dirty="0">
                 <a:solidFill>
                   <a:srgbClr val="1B2A44"/>
                 </a:solidFill>
@@ -10770,7 +10770,7 @@
               </a:rPr>
               <a:t>Trois acteurs, treize cas d'utilisation</a:t>
             </a:r>
-            <a:endParaRPr lang="en-US" sz="1150" dirty="0"/>
+            <a:endParaRPr lang="en-US" sz="1300" dirty="0"/>
           </a:p>
         </p:txBody>
       </p:sp>
@@ -10782,7 +10782,7 @@
         </p:nvSpPr>
         <p:spPr>
           <a:xfrm>
-            <a:off x="8641080" y="2505456"/>
+            <a:off x="6446520" y="2688336"/>
             <a:ext cx="109728" cy="109728"/>
           </a:xfrm>
           <a:prstGeom prst="ellipse">
@@ -10807,8 +10807,8 @@
         </p:nvSpPr>
         <p:spPr>
           <a:xfrm>
-            <a:off x="8915400" y="2359152"/>
-            <a:ext cx="2743200" cy="420624"/>
+            <a:off x="6720840" y="2542032"/>
+            <a:ext cx="4846320" cy="420624"/>
           </a:xfrm>
           <a:prstGeom prst="rect">
             <a:avLst/>
@@ -10824,7 +10824,7 @@
               <a:buNone/>
             </a:pPr>
             <a:r>
-              <a:rPr lang="en-US" sz="1150" dirty="0">
+              <a:rPr lang="en-US" sz="1300" dirty="0">
                 <a:solidFill>
                   <a:srgbClr val="1B2A44"/>
                 </a:solidFill>
@@ -10834,7 +10834,7 @@
               </a:rPr>
               <a:t>Chaque cas inclut « S'authentifier » (include)</a:t>
             </a:r>
-            <a:endParaRPr lang="en-US" sz="1150" dirty="0"/>
+            <a:endParaRPr lang="en-US" sz="1300" dirty="0"/>
           </a:p>
         </p:txBody>
       </p:sp>
@@ -10846,7 +10846,7 @@
         </p:nvSpPr>
         <p:spPr>
           <a:xfrm>
-            <a:off x="8641080" y="2962656"/>
+            <a:off x="6446520" y="3145536"/>
             <a:ext cx="109728" cy="109728"/>
           </a:xfrm>
           <a:prstGeom prst="ellipse">
@@ -10871,8 +10871,8 @@
         </p:nvSpPr>
         <p:spPr>
           <a:xfrm>
-            <a:off x="8915400" y="2816352"/>
-            <a:ext cx="2743200" cy="420624"/>
+            <a:off x="6720840" y="2999232"/>
+            <a:ext cx="4846320" cy="420624"/>
           </a:xfrm>
           <a:prstGeom prst="rect">
             <a:avLst/>
@@ -10888,7 +10888,7 @@
               <a:buNone/>
             </a:pPr>
             <a:r>
-              <a:rPr lang="en-US" sz="1150" dirty="0">
+              <a:rPr lang="en-US" sz="1300" dirty="0">
                 <a:solidFill>
                   <a:srgbClr val="1B2A44"/>
                 </a:solidFill>
@@ -10898,7 +10898,7 @@
               </a:rPr>
               <a:t>Administrateur : les 13 cas, sans exception</a:t>
             </a:r>
-            <a:endParaRPr lang="en-US" sz="1150" dirty="0"/>
+            <a:endParaRPr lang="en-US" sz="1300" dirty="0"/>
           </a:p>
         </p:txBody>
       </p:sp>
@@ -10910,7 +10910,7 @@
         </p:nvSpPr>
         <p:spPr>
           <a:xfrm>
-            <a:off x="8641080" y="3419856"/>
+            <a:off x="6446520" y="3602736"/>
             <a:ext cx="109728" cy="109728"/>
           </a:xfrm>
           <a:prstGeom prst="ellipse">
@@ -10935,8 +10935,8 @@
         </p:nvSpPr>
         <p:spPr>
           <a:xfrm>
-            <a:off x="8915400" y="3273552"/>
-            <a:ext cx="2743200" cy="420624"/>
+            <a:off x="6720840" y="3456432"/>
+            <a:ext cx="4846320" cy="420624"/>
           </a:xfrm>
           <a:prstGeom prst="rect">
             <a:avLst/>
@@ -10952,7 +10952,7 @@
               <a:buNone/>
             </a:pPr>
             <a:r>
-              <a:rPr lang="en-US" sz="1150" dirty="0">
+              <a:rPr lang="en-US" sz="1300" dirty="0">
                 <a:solidFill>
                   <a:srgbClr val="1B2A44"/>
                 </a:solidFill>
@@ -10962,7 +10962,7 @@
               </a:rPr>
               <a:t>Directeur commercial : 5 cas, dont les employés en consultation</a:t>
             </a:r>
-            <a:endParaRPr lang="en-US" sz="1150" dirty="0"/>
+            <a:endParaRPr lang="en-US" sz="1300" dirty="0"/>
           </a:p>
         </p:txBody>
       </p:sp>
@@ -10974,7 +10974,7 @@
         </p:nvSpPr>
         <p:spPr>
           <a:xfrm>
-            <a:off x="8641080" y="3877056"/>
+            <a:off x="6446520" y="4059936"/>
             <a:ext cx="109728" cy="109728"/>
           </a:xfrm>
           <a:prstGeom prst="ellipse">
@@ -10999,8 +10999,8 @@
         </p:nvSpPr>
         <p:spPr>
           <a:xfrm>
-            <a:off x="8915400" y="3730752"/>
-            <a:ext cx="2743200" cy="420624"/>
+            <a:off x="6720840" y="3913632"/>
+            <a:ext cx="4846320" cy="420624"/>
           </a:xfrm>
           <a:prstGeom prst="rect">
             <a:avLst/>
@@ -11016,7 +11016,7 @@
               <a:buNone/>
             </a:pPr>
             <a:r>
-              <a:rPr lang="en-US" sz="1150" dirty="0">
+              <a:rPr lang="en-US" sz="1300" dirty="0">
                 <a:solidFill>
                   <a:srgbClr val="1B2A44"/>
                 </a:solidFill>
@@ -11026,7 +11026,7 @@
               </a:rPr>
               <a:t>Utilisateur : 3 cas — pointage, demandes, notifications</a:t>
             </a:r>
-            <a:endParaRPr lang="en-US" sz="1150" dirty="0"/>
+            <a:endParaRPr lang="en-US" sz="1300" dirty="0"/>
           </a:p>
         </p:txBody>
       </p:sp>

</xml_diff>